<commit_message>
Update Project 2 courseware to October 19 revision
</commit_message>
<xml_diff>
--- a/content/projects/project2/materials/Project_2_release.pptx
+++ b/content/projects/project2/materials/Project_2_release.pptx
@@ -82,13 +82,13 @@
         </a:solidFill>
         <a:effectLst/>
         <a:uFillTx/>
-        <a:latin typeface="Calibri"/>
-        <a:ea typeface="Calibri"/>
-        <a:cs typeface="Calibri"/>
-        <a:sym typeface="Calibri"/>
+        <a:latin typeface="+mj-lt"/>
+        <a:ea typeface="+mj-ea"/>
+        <a:cs typeface="+mj-cs"/>
+        <a:sym typeface="Helvetica"/>
       </a:defRPr>
     </a:lvl1pPr>
-    <a:lvl2pPr marL="0" marR="0" indent="457200" algn="l" defTabSz="457200" rtl="0" fontAlgn="auto" latinLnBrk="0" hangingPunct="0">
+    <a:lvl2pPr marL="0" marR="0" indent="0" algn="l" defTabSz="457200" rtl="0" fontAlgn="auto" latinLnBrk="0" hangingPunct="0">
       <a:lnSpc>
         <a:spcPct val="100000"/>
       </a:lnSpc>
@@ -112,13 +112,13 @@
         </a:solidFill>
         <a:effectLst/>
         <a:uFillTx/>
-        <a:latin typeface="Calibri"/>
-        <a:ea typeface="Calibri"/>
-        <a:cs typeface="Calibri"/>
-        <a:sym typeface="Calibri"/>
+        <a:latin typeface="+mj-lt"/>
+        <a:ea typeface="+mj-ea"/>
+        <a:cs typeface="+mj-cs"/>
+        <a:sym typeface="Helvetica"/>
       </a:defRPr>
     </a:lvl2pPr>
-    <a:lvl3pPr marL="0" marR="0" indent="914400" algn="l" defTabSz="457200" rtl="0" fontAlgn="auto" latinLnBrk="0" hangingPunct="0">
+    <a:lvl3pPr marL="0" marR="0" indent="0" algn="l" defTabSz="457200" rtl="0" fontAlgn="auto" latinLnBrk="0" hangingPunct="0">
       <a:lnSpc>
         <a:spcPct val="100000"/>
       </a:lnSpc>
@@ -142,13 +142,13 @@
         </a:solidFill>
         <a:effectLst/>
         <a:uFillTx/>
-        <a:latin typeface="Calibri"/>
-        <a:ea typeface="Calibri"/>
-        <a:cs typeface="Calibri"/>
-        <a:sym typeface="Calibri"/>
+        <a:latin typeface="+mj-lt"/>
+        <a:ea typeface="+mj-ea"/>
+        <a:cs typeface="+mj-cs"/>
+        <a:sym typeface="Helvetica"/>
       </a:defRPr>
     </a:lvl3pPr>
-    <a:lvl4pPr marL="0" marR="0" indent="1371600" algn="l" defTabSz="457200" rtl="0" fontAlgn="auto" latinLnBrk="0" hangingPunct="0">
+    <a:lvl4pPr marL="0" marR="0" indent="0" algn="l" defTabSz="457200" rtl="0" fontAlgn="auto" latinLnBrk="0" hangingPunct="0">
       <a:lnSpc>
         <a:spcPct val="100000"/>
       </a:lnSpc>
@@ -172,13 +172,13 @@
         </a:solidFill>
         <a:effectLst/>
         <a:uFillTx/>
-        <a:latin typeface="Calibri"/>
-        <a:ea typeface="Calibri"/>
-        <a:cs typeface="Calibri"/>
-        <a:sym typeface="Calibri"/>
+        <a:latin typeface="+mj-lt"/>
+        <a:ea typeface="+mj-ea"/>
+        <a:cs typeface="+mj-cs"/>
+        <a:sym typeface="Helvetica"/>
       </a:defRPr>
     </a:lvl4pPr>
-    <a:lvl5pPr marL="0" marR="0" indent="1828800" algn="l" defTabSz="457200" rtl="0" fontAlgn="auto" latinLnBrk="0" hangingPunct="0">
+    <a:lvl5pPr marL="0" marR="0" indent="0" algn="l" defTabSz="457200" rtl="0" fontAlgn="auto" latinLnBrk="0" hangingPunct="0">
       <a:lnSpc>
         <a:spcPct val="100000"/>
       </a:lnSpc>
@@ -202,13 +202,13 @@
         </a:solidFill>
         <a:effectLst/>
         <a:uFillTx/>
-        <a:latin typeface="Calibri"/>
-        <a:ea typeface="Calibri"/>
-        <a:cs typeface="Calibri"/>
-        <a:sym typeface="Calibri"/>
+        <a:latin typeface="+mj-lt"/>
+        <a:ea typeface="+mj-ea"/>
+        <a:cs typeface="+mj-cs"/>
+        <a:sym typeface="Helvetica"/>
       </a:defRPr>
     </a:lvl5pPr>
-    <a:lvl6pPr marL="0" marR="0" indent="2286000" algn="l" defTabSz="457200" rtl="0" fontAlgn="auto" latinLnBrk="0" hangingPunct="0">
+    <a:lvl6pPr marL="0" marR="0" indent="0" algn="l" defTabSz="457200" rtl="0" fontAlgn="auto" latinLnBrk="0" hangingPunct="0">
       <a:lnSpc>
         <a:spcPct val="100000"/>
       </a:lnSpc>
@@ -232,13 +232,13 @@
         </a:solidFill>
         <a:effectLst/>
         <a:uFillTx/>
-        <a:latin typeface="Calibri"/>
-        <a:ea typeface="Calibri"/>
-        <a:cs typeface="Calibri"/>
-        <a:sym typeface="Calibri"/>
+        <a:latin typeface="+mj-lt"/>
+        <a:ea typeface="+mj-ea"/>
+        <a:cs typeface="+mj-cs"/>
+        <a:sym typeface="Helvetica"/>
       </a:defRPr>
     </a:lvl6pPr>
-    <a:lvl7pPr marL="0" marR="0" indent="2743200" algn="l" defTabSz="457200" rtl="0" fontAlgn="auto" latinLnBrk="0" hangingPunct="0">
+    <a:lvl7pPr marL="0" marR="0" indent="0" algn="l" defTabSz="457200" rtl="0" fontAlgn="auto" latinLnBrk="0" hangingPunct="0">
       <a:lnSpc>
         <a:spcPct val="100000"/>
       </a:lnSpc>
@@ -262,13 +262,13 @@
         </a:solidFill>
         <a:effectLst/>
         <a:uFillTx/>
-        <a:latin typeface="Calibri"/>
-        <a:ea typeface="Calibri"/>
-        <a:cs typeface="Calibri"/>
-        <a:sym typeface="Calibri"/>
+        <a:latin typeface="+mj-lt"/>
+        <a:ea typeface="+mj-ea"/>
+        <a:cs typeface="+mj-cs"/>
+        <a:sym typeface="Helvetica"/>
       </a:defRPr>
     </a:lvl7pPr>
-    <a:lvl8pPr marL="0" marR="0" indent="3200400" algn="l" defTabSz="457200" rtl="0" fontAlgn="auto" latinLnBrk="0" hangingPunct="0">
+    <a:lvl8pPr marL="0" marR="0" indent="0" algn="l" defTabSz="457200" rtl="0" fontAlgn="auto" latinLnBrk="0" hangingPunct="0">
       <a:lnSpc>
         <a:spcPct val="100000"/>
       </a:lnSpc>
@@ -292,13 +292,13 @@
         </a:solidFill>
         <a:effectLst/>
         <a:uFillTx/>
-        <a:latin typeface="Calibri"/>
-        <a:ea typeface="Calibri"/>
-        <a:cs typeface="Calibri"/>
-        <a:sym typeface="Calibri"/>
+        <a:latin typeface="+mj-lt"/>
+        <a:ea typeface="+mj-ea"/>
+        <a:cs typeface="+mj-cs"/>
+        <a:sym typeface="Helvetica"/>
       </a:defRPr>
     </a:lvl8pPr>
-    <a:lvl9pPr marL="0" marR="0" indent="3657600" algn="l" defTabSz="457200" rtl="0" fontAlgn="auto" latinLnBrk="0" hangingPunct="0">
+    <a:lvl9pPr marL="0" marR="0" indent="0" algn="l" defTabSz="457200" rtl="0" fontAlgn="auto" latinLnBrk="0" hangingPunct="0">
       <a:lnSpc>
         <a:spcPct val="100000"/>
       </a:lnSpc>
@@ -322,10 +322,10 @@
         </a:solidFill>
         <a:effectLst/>
         <a:uFillTx/>
-        <a:latin typeface="Calibri"/>
-        <a:ea typeface="Calibri"/>
-        <a:cs typeface="Calibri"/>
-        <a:sym typeface="Calibri"/>
+        <a:latin typeface="+mj-lt"/>
+        <a:ea typeface="+mj-ea"/>
+        <a:cs typeface="+mj-cs"/>
+        <a:sym typeface="Helvetica"/>
       </a:defRPr>
     </a:lvl9pPr>
   </p:defaultTextStyle>
@@ -409,73 +409,73 @@
   <p:notesStyle>
     <a:lvl1pPr latinLnBrk="0">
       <a:defRPr sz="1200">
-        <a:latin typeface="+mj-lt"/>
-        <a:ea typeface="+mj-ea"/>
-        <a:cs typeface="+mj-cs"/>
+        <a:latin typeface="+mn-lt"/>
+        <a:ea typeface="+mn-ea"/>
+        <a:cs typeface="+mn-cs"/>
         <a:sym typeface="等线"/>
       </a:defRPr>
     </a:lvl1pPr>
     <a:lvl2pPr indent="228600" latinLnBrk="0">
       <a:defRPr sz="1200">
-        <a:latin typeface="+mj-lt"/>
-        <a:ea typeface="+mj-ea"/>
-        <a:cs typeface="+mj-cs"/>
+        <a:latin typeface="+mn-lt"/>
+        <a:ea typeface="+mn-ea"/>
+        <a:cs typeface="+mn-cs"/>
         <a:sym typeface="等线"/>
       </a:defRPr>
     </a:lvl2pPr>
     <a:lvl3pPr indent="457200" latinLnBrk="0">
       <a:defRPr sz="1200">
-        <a:latin typeface="+mj-lt"/>
-        <a:ea typeface="+mj-ea"/>
-        <a:cs typeface="+mj-cs"/>
+        <a:latin typeface="+mn-lt"/>
+        <a:ea typeface="+mn-ea"/>
+        <a:cs typeface="+mn-cs"/>
         <a:sym typeface="等线"/>
       </a:defRPr>
     </a:lvl3pPr>
     <a:lvl4pPr indent="685800" latinLnBrk="0">
       <a:defRPr sz="1200">
-        <a:latin typeface="+mj-lt"/>
-        <a:ea typeface="+mj-ea"/>
-        <a:cs typeface="+mj-cs"/>
+        <a:latin typeface="+mn-lt"/>
+        <a:ea typeface="+mn-ea"/>
+        <a:cs typeface="+mn-cs"/>
         <a:sym typeface="等线"/>
       </a:defRPr>
     </a:lvl4pPr>
     <a:lvl5pPr indent="914400" latinLnBrk="0">
       <a:defRPr sz="1200">
-        <a:latin typeface="+mj-lt"/>
-        <a:ea typeface="+mj-ea"/>
-        <a:cs typeface="+mj-cs"/>
+        <a:latin typeface="+mn-lt"/>
+        <a:ea typeface="+mn-ea"/>
+        <a:cs typeface="+mn-cs"/>
         <a:sym typeface="等线"/>
       </a:defRPr>
     </a:lvl5pPr>
     <a:lvl6pPr indent="1143000" latinLnBrk="0">
       <a:defRPr sz="1200">
-        <a:latin typeface="+mj-lt"/>
-        <a:ea typeface="+mj-ea"/>
-        <a:cs typeface="+mj-cs"/>
+        <a:latin typeface="+mn-lt"/>
+        <a:ea typeface="+mn-ea"/>
+        <a:cs typeface="+mn-cs"/>
         <a:sym typeface="等线"/>
       </a:defRPr>
     </a:lvl6pPr>
     <a:lvl7pPr indent="1371600" latinLnBrk="0">
       <a:defRPr sz="1200">
-        <a:latin typeface="+mj-lt"/>
-        <a:ea typeface="+mj-ea"/>
-        <a:cs typeface="+mj-cs"/>
+        <a:latin typeface="+mn-lt"/>
+        <a:ea typeface="+mn-ea"/>
+        <a:cs typeface="+mn-cs"/>
         <a:sym typeface="等线"/>
       </a:defRPr>
     </a:lvl7pPr>
     <a:lvl8pPr indent="1600200" latinLnBrk="0">
       <a:defRPr sz="1200">
-        <a:latin typeface="+mj-lt"/>
-        <a:ea typeface="+mj-ea"/>
-        <a:cs typeface="+mj-cs"/>
+        <a:latin typeface="+mn-lt"/>
+        <a:ea typeface="+mn-ea"/>
+        <a:cs typeface="+mn-cs"/>
         <a:sym typeface="等线"/>
       </a:defRPr>
     </a:lvl8pPr>
     <a:lvl9pPr indent="1828800" latinLnBrk="0">
       <a:defRPr sz="1200">
-        <a:latin typeface="+mj-lt"/>
-        <a:ea typeface="+mj-ea"/>
-        <a:cs typeface="+mj-cs"/>
+        <a:latin typeface="+mn-lt"/>
+        <a:ea typeface="+mn-ea"/>
+        <a:cs typeface="+mn-cs"/>
         <a:sym typeface="等线"/>
       </a:defRPr>
     </a:lvl9pPr>
@@ -540,16 +540,7 @@
           <a:p>
             <a:pPr/>
             <a:r>
-              <a:t>distinct</a:t>
-            </a:r>
-            <a:r>
-              <a:t>不像</a:t>
-            </a:r>
-            <a:r>
-              <a:t>mysql</a:t>
-            </a:r>
-            <a:r>
-              <a:t>那样方便，所以</a:t>
+              <a:t>distinct不像mysql那样方便，所以</a:t>
             </a:r>
           </a:p>
         </p:txBody>
@@ -622,7 +613,7 @@
         <p:spPr>
           <a:xfrm>
             <a:off x="1524000" y="3602037"/>
-            <a:ext cx="9144000" cy="1655763"/>
+            <a:ext cx="9144000" cy="1655764"/>
           </a:xfrm>
           <a:prstGeom prst="rect">
             <a:avLst/>
@@ -637,25 +628,25 @@
               <a:buNone/>
               <a:defRPr sz="2400"/>
             </a:lvl1pPr>
-            <a:lvl2pPr marL="0" indent="457200" algn="ctr">
+            <a:lvl2pPr marL="0" indent="0" algn="ctr">
               <a:buSzTx/>
               <a:buFontTx/>
               <a:buNone/>
               <a:defRPr sz="2400"/>
             </a:lvl2pPr>
-            <a:lvl3pPr marL="0" indent="914400" algn="ctr">
+            <a:lvl3pPr marL="0" indent="0" algn="ctr">
               <a:buSzTx/>
               <a:buFontTx/>
               <a:buNone/>
               <a:defRPr sz="2400"/>
             </a:lvl3pPr>
-            <a:lvl4pPr marL="0" indent="1371600" algn="ctr">
+            <a:lvl4pPr marL="0" indent="0" algn="ctr">
               <a:buSzTx/>
               <a:buFontTx/>
               <a:buNone/>
               <a:defRPr sz="2400"/>
             </a:lvl4pPr>
-            <a:lvl5pPr marL="0" indent="1828800" algn="ctr">
+            <a:lvl5pPr marL="0" indent="0" algn="ctr">
               <a:buSzTx/>
               <a:buFontTx/>
               <a:buNone/>
@@ -905,7 +896,7 @@
         <p:spPr>
           <a:xfrm>
             <a:off x="831850" y="4589464"/>
-            <a:ext cx="10515601" cy="1500188"/>
+            <a:ext cx="10515601" cy="1500189"/>
           </a:xfrm>
           <a:prstGeom prst="rect">
             <a:avLst/>
@@ -920,25 +911,25 @@
               <a:buNone/>
               <a:defRPr sz="2400"/>
             </a:lvl1pPr>
-            <a:lvl2pPr marL="0" indent="457200">
+            <a:lvl2pPr marL="0" indent="0">
               <a:buSzTx/>
               <a:buFontTx/>
               <a:buNone/>
               <a:defRPr sz="2400"/>
             </a:lvl2pPr>
-            <a:lvl3pPr marL="0" indent="914400">
+            <a:lvl3pPr marL="0" indent="0">
               <a:buSzTx/>
               <a:buFontTx/>
               <a:buNone/>
               <a:defRPr sz="2400"/>
             </a:lvl3pPr>
-            <a:lvl4pPr marL="0" indent="1371600">
+            <a:lvl4pPr marL="0" indent="0">
               <a:buSzTx/>
               <a:buFontTx/>
               <a:buNone/>
               <a:defRPr sz="2400"/>
             </a:lvl4pPr>
-            <a:lvl5pPr marL="0" indent="1828800">
+            <a:lvl5pPr marL="0" indent="0">
               <a:buSzTx/>
               <a:buFontTx/>
               <a:buNone/>
@@ -1187,8 +1178,8 @@
         </p:nvSpPr>
         <p:spPr>
           <a:xfrm>
-            <a:off x="839788" y="1681163"/>
-            <a:ext cx="5157789" cy="823913"/>
+            <a:off x="839787" y="1681163"/>
+            <a:ext cx="5157791" cy="823914"/>
           </a:xfrm>
           <a:prstGeom prst="rect">
             <a:avLst/>
@@ -1203,25 +1194,25 @@
               <a:buNone/>
               <a:defRPr b="1" sz="2400"/>
             </a:lvl1pPr>
-            <a:lvl2pPr marL="0" indent="457200">
+            <a:lvl2pPr marL="0" indent="0">
               <a:buSzTx/>
               <a:buFontTx/>
               <a:buNone/>
               <a:defRPr b="1" sz="2400"/>
             </a:lvl2pPr>
-            <a:lvl3pPr marL="0" indent="914400">
+            <a:lvl3pPr marL="0" indent="0">
               <a:buSzTx/>
               <a:buFontTx/>
               <a:buNone/>
               <a:defRPr b="1" sz="2400"/>
             </a:lvl3pPr>
-            <a:lvl4pPr marL="0" indent="1371600">
+            <a:lvl4pPr marL="0" indent="0">
               <a:buSzTx/>
               <a:buFontTx/>
               <a:buNone/>
               <a:defRPr b="1" sz="2400"/>
             </a:lvl4pPr>
-            <a:lvl5pPr marL="0" indent="1828800">
+            <a:lvl5pPr marL="0" indent="0">
               <a:buSzTx/>
               <a:buFontTx/>
               <a:buNone/>
@@ -1271,7 +1262,7 @@
         <p:spPr>
           <a:xfrm>
             <a:off x="6172201" y="1681163"/>
-            <a:ext cx="5183189" cy="823913"/>
+            <a:ext cx="5183190" cy="823914"/>
           </a:xfrm>
           <a:prstGeom prst="rect">
             <a:avLst/>
@@ -1281,12 +1272,7 @@
           <a:bodyPr anchor="b"/>
           <a:lstStyle/>
           <a:p>
-            <a:pPr marL="0" indent="0">
-              <a:buSzTx/>
-              <a:buFontTx/>
-              <a:buNone/>
-              <a:defRPr b="1" sz="2400"/>
-            </a:pPr>
+            <a:pPr/>
           </a:p>
         </p:txBody>
       </p:sp>
@@ -1469,7 +1455,7 @@
         <p:spPr>
           <a:xfrm>
             <a:off x="839787" y="457200"/>
-            <a:ext cx="3932239" cy="1600200"/>
+            <a:ext cx="3932240" cy="1600200"/>
           </a:xfrm>
           <a:prstGeom prst="rect">
             <a:avLst/>
@@ -1501,7 +1487,7 @@
         <p:spPr>
           <a:xfrm>
             <a:off x="5183187" y="987427"/>
-            <a:ext cx="6172201" cy="4873626"/>
+            <a:ext cx="6172202" cy="4873627"/>
           </a:xfrm>
           <a:prstGeom prst="rect">
             <a:avLst/>
@@ -1568,8 +1554,8 @@
         </p:nvSpPr>
         <p:spPr>
           <a:xfrm>
-            <a:off x="839787" y="2057400"/>
-            <a:ext cx="3932239" cy="3811588"/>
+            <a:off x="839786" y="2057400"/>
+            <a:ext cx="3932241" cy="3811588"/>
           </a:xfrm>
           <a:prstGeom prst="rect">
             <a:avLst/>
@@ -1579,12 +1565,7 @@
           <a:bodyPr/>
           <a:lstStyle/>
           <a:p>
-            <a:pPr marL="0" indent="0">
-              <a:buSzTx/>
-              <a:buFontTx/>
-              <a:buNone/>
-              <a:defRPr sz="1600"/>
-            </a:pPr>
+            <a:pPr/>
           </a:p>
         </p:txBody>
       </p:sp>
@@ -1647,7 +1628,7 @@
         <p:spPr>
           <a:xfrm>
             <a:off x="839787" y="457200"/>
-            <a:ext cx="3932239" cy="1600200"/>
+            <a:ext cx="3932240" cy="1600200"/>
           </a:xfrm>
           <a:prstGeom prst="rect">
             <a:avLst/>
@@ -1679,14 +1660,14 @@
         <p:spPr>
           <a:xfrm>
             <a:off x="5183187" y="987427"/>
-            <a:ext cx="6172201" cy="4873626"/>
+            <a:ext cx="6172202" cy="4873627"/>
           </a:xfrm>
           <a:prstGeom prst="rect">
             <a:avLst/>
           </a:prstGeom>
         </p:spPr>
         <p:txBody>
-          <a:bodyPr lIns="91439" rIns="91439">
+          <a:bodyPr lIns="91439" tIns="45719" rIns="91439" bIns="45719">
             <a:noAutofit/>
           </a:bodyPr>
           <a:lstStyle/>
@@ -1706,7 +1687,7 @@
         <p:spPr>
           <a:xfrm>
             <a:off x="839787" y="2057400"/>
-            <a:ext cx="3932239" cy="3811588"/>
+            <a:ext cx="3932240" cy="3811588"/>
           </a:xfrm>
           <a:prstGeom prst="rect">
             <a:avLst/>
@@ -1721,25 +1702,25 @@
               <a:buNone/>
               <a:defRPr sz="1600"/>
             </a:lvl1pPr>
-            <a:lvl2pPr marL="0" indent="457200">
+            <a:lvl2pPr marL="0" indent="0">
               <a:buSzTx/>
               <a:buFontTx/>
               <a:buNone/>
               <a:defRPr sz="1600"/>
             </a:lvl2pPr>
-            <a:lvl3pPr marL="0" indent="914400">
+            <a:lvl3pPr marL="0" indent="0">
               <a:buSzTx/>
               <a:buFontTx/>
               <a:buNone/>
               <a:defRPr sz="1600"/>
             </a:lvl3pPr>
-            <a:lvl4pPr marL="0" indent="1371600">
+            <a:lvl4pPr marL="0" indent="0">
               <a:buSzTx/>
               <a:buFontTx/>
               <a:buNone/>
               <a:defRPr sz="1600"/>
             </a:lvl4pPr>
-            <a:lvl5pPr marL="0" indent="1828800">
+            <a:lvl5pPr marL="0" indent="0">
               <a:buSzTx/>
               <a:buFontTx/>
               <a:buNone/>
@@ -1859,7 +1840,7 @@
           </a:extLst>
         </p:spPr>
         <p:txBody>
-          <a:bodyPr lIns="45719" rIns="45719" anchor="ctr">
+          <a:bodyPr lIns="45718" tIns="45718" rIns="45718" bIns="45718" anchor="ctr">
             <a:normAutofit fontScale="100000" lnSpcReduction="0"/>
           </a:bodyPr>
           <a:lstStyle/>
@@ -1897,7 +1878,7 @@
           </a:extLst>
         </p:spPr>
         <p:txBody>
-          <a:bodyPr lIns="45719" rIns="45719">
+          <a:bodyPr lIns="45718" tIns="45718" rIns="45718" bIns="45718">
             <a:normAutofit fontScale="100000" lnSpcReduction="0"/>
           </a:bodyPr>
           <a:lstStyle/>
@@ -1943,8 +1924,8 @@
         </p:nvSpPr>
         <p:spPr>
           <a:xfrm>
-            <a:off x="11095176" y="6414762"/>
-            <a:ext cx="258624" cy="248305"/>
+            <a:off x="11095178" y="6414763"/>
+            <a:ext cx="258623" cy="248303"/>
           </a:xfrm>
           <a:prstGeom prst="rect">
             <a:avLst/>
@@ -1954,7 +1935,7 @@
           </a:ln>
         </p:spPr>
         <p:txBody>
-          <a:bodyPr wrap="none" lIns="45719" rIns="45719" anchor="ctr">
+          <a:bodyPr wrap="none" lIns="45718" tIns="45718" rIns="45718" bIns="45718" anchor="ctr">
             <a:spAutoFit/>
           </a:bodyPr>
           <a:lstStyle>
@@ -1963,6 +1944,10 @@
                 <a:solidFill>
                   <a:srgbClr val="888888"/>
                 </a:solidFill>
+                <a:latin typeface="Calibri"/>
+                <a:ea typeface="Calibri"/>
+                <a:cs typeface="Calibri"/>
+                <a:sym typeface="Calibri"/>
               </a:defRPr>
             </a:lvl1pPr>
           </a:lstStyle>
@@ -2277,7 +2262,7 @@
           <a:sym typeface="Calibri"/>
         </a:defRPr>
       </a:lvl2pPr>
-      <a:lvl3pPr marL="1234439" marR="0" indent="-320039" algn="l" defTabSz="914400" rtl="0" latinLnBrk="0">
+      <a:lvl3pPr marL="1234438" marR="0" indent="-320038" algn="l" defTabSz="914400" rtl="0" latinLnBrk="0">
         <a:lnSpc>
           <a:spcPct val="90000"/>
         </a:lnSpc>
@@ -2487,7 +2472,7 @@
           <a:sym typeface="Calibri"/>
         </a:defRPr>
       </a:lvl1pPr>
-      <a:lvl2pPr marL="0" marR="0" indent="457200" algn="r" defTabSz="457200" rtl="0" latinLnBrk="0">
+      <a:lvl2pPr marL="0" marR="0" indent="0" algn="r" defTabSz="457200" rtl="0" latinLnBrk="0">
         <a:lnSpc>
           <a:spcPct val="100000"/>
         </a:lnSpc>
@@ -2513,7 +2498,7 @@
           <a:sym typeface="Calibri"/>
         </a:defRPr>
       </a:lvl2pPr>
-      <a:lvl3pPr marL="0" marR="0" indent="914400" algn="r" defTabSz="457200" rtl="0" latinLnBrk="0">
+      <a:lvl3pPr marL="0" marR="0" indent="0" algn="r" defTabSz="457200" rtl="0" latinLnBrk="0">
         <a:lnSpc>
           <a:spcPct val="100000"/>
         </a:lnSpc>
@@ -2539,7 +2524,7 @@
           <a:sym typeface="Calibri"/>
         </a:defRPr>
       </a:lvl3pPr>
-      <a:lvl4pPr marL="0" marR="0" indent="1371600" algn="r" defTabSz="457200" rtl="0" latinLnBrk="0">
+      <a:lvl4pPr marL="0" marR="0" indent="0" algn="r" defTabSz="457200" rtl="0" latinLnBrk="0">
         <a:lnSpc>
           <a:spcPct val="100000"/>
         </a:lnSpc>
@@ -2565,7 +2550,7 @@
           <a:sym typeface="Calibri"/>
         </a:defRPr>
       </a:lvl4pPr>
-      <a:lvl5pPr marL="0" marR="0" indent="1828800" algn="r" defTabSz="457200" rtl="0" latinLnBrk="0">
+      <a:lvl5pPr marL="0" marR="0" indent="0" algn="r" defTabSz="457200" rtl="0" latinLnBrk="0">
         <a:lnSpc>
           <a:spcPct val="100000"/>
         </a:lnSpc>
@@ -2591,7 +2576,7 @@
           <a:sym typeface="Calibri"/>
         </a:defRPr>
       </a:lvl5pPr>
-      <a:lvl6pPr marL="0" marR="0" indent="2286000" algn="r" defTabSz="457200" rtl="0" latinLnBrk="0">
+      <a:lvl6pPr marL="0" marR="0" indent="0" algn="r" defTabSz="457200" rtl="0" latinLnBrk="0">
         <a:lnSpc>
           <a:spcPct val="100000"/>
         </a:lnSpc>
@@ -2617,7 +2602,7 @@
           <a:sym typeface="Calibri"/>
         </a:defRPr>
       </a:lvl6pPr>
-      <a:lvl7pPr marL="0" marR="0" indent="2743200" algn="r" defTabSz="457200" rtl="0" latinLnBrk="0">
+      <a:lvl7pPr marL="0" marR="0" indent="0" algn="r" defTabSz="457200" rtl="0" latinLnBrk="0">
         <a:lnSpc>
           <a:spcPct val="100000"/>
         </a:lnSpc>
@@ -2643,7 +2628,7 @@
           <a:sym typeface="Calibri"/>
         </a:defRPr>
       </a:lvl7pPr>
-      <a:lvl8pPr marL="0" marR="0" indent="3200400" algn="r" defTabSz="457200" rtl="0" latinLnBrk="0">
+      <a:lvl8pPr marL="0" marR="0" indent="0" algn="r" defTabSz="457200" rtl="0" latinLnBrk="0">
         <a:lnSpc>
           <a:spcPct val="100000"/>
         </a:lnSpc>
@@ -2669,7 +2654,7 @@
           <a:sym typeface="Calibri"/>
         </a:defRPr>
       </a:lvl8pPr>
-      <a:lvl9pPr marL="0" marR="0" indent="3657600" algn="r" defTabSz="457200" rtl="0" latinLnBrk="0">
+      <a:lvl9pPr marL="0" marR="0" indent="0" algn="r" defTabSz="457200" rtl="0" latinLnBrk="0">
         <a:lnSpc>
           <a:spcPct val="100000"/>
         </a:lnSpc>
@@ -2725,8 +2710,8 @@
         </p:nvSpPr>
         <p:spPr>
           <a:xfrm>
-            <a:off x="1394460" y="2111998"/>
-            <a:ext cx="9403080" cy="935370"/>
+            <a:off x="1394459" y="2111999"/>
+            <a:ext cx="9403082" cy="935368"/>
           </a:xfrm>
           <a:prstGeom prst="rect">
             <a:avLst/>
@@ -2741,7 +2726,7 @@
           </a:extLst>
         </p:spPr>
         <p:txBody>
-          <a:bodyPr lIns="45719" rIns="45719">
+          <a:bodyPr lIns="45718" tIns="45718" rIns="45718" bIns="45718">
             <a:spAutoFit/>
           </a:bodyPr>
           <a:lstStyle>
@@ -2773,8 +2758,8 @@
         </p:nvSpPr>
         <p:spPr>
           <a:xfrm>
-            <a:off x="4176451" y="4571381"/>
-            <a:ext cx="3537759" cy="666760"/>
+            <a:off x="4176450" y="4571382"/>
+            <a:ext cx="3537759" cy="666758"/>
           </a:xfrm>
           <a:prstGeom prst="rect">
             <a:avLst/>
@@ -2789,7 +2774,7 @@
           </a:extLst>
         </p:spPr>
         <p:txBody>
-          <a:bodyPr lIns="45719" rIns="45719">
+          <a:bodyPr lIns="45718" tIns="45718" rIns="45718" bIns="45718">
             <a:spAutoFit/>
           </a:bodyPr>
           <a:lstStyle>
@@ -2818,8 +2803,8 @@
         </p:nvSpPr>
         <p:spPr>
           <a:xfrm>
-            <a:off x="3440081" y="3495578"/>
-            <a:ext cx="5263345" cy="666761"/>
+            <a:off x="3440081" y="3495579"/>
+            <a:ext cx="5263346" cy="666759"/>
           </a:xfrm>
           <a:prstGeom prst="rect">
             <a:avLst/>
@@ -2834,7 +2819,7 @@
           </a:extLst>
         </p:spPr>
         <p:txBody>
-          <a:bodyPr lIns="45719" rIns="45719">
+          <a:bodyPr lIns="45718" tIns="45718" rIns="45718" bIns="45718">
             <a:spAutoFit/>
           </a:bodyPr>
           <a:lstStyle>
@@ -2889,8 +2874,8 @@
         </p:nvSpPr>
         <p:spPr>
           <a:xfrm>
-            <a:off x="531892" y="205503"/>
-            <a:ext cx="10882867" cy="935370"/>
+            <a:off x="531891" y="205503"/>
+            <a:ext cx="10882869" cy="935369"/>
           </a:xfrm>
           <a:prstGeom prst="rect">
             <a:avLst/>
@@ -2905,7 +2890,7 @@
           </a:extLst>
         </p:spPr>
         <p:txBody>
-          <a:bodyPr lIns="45719" rIns="45719">
+          <a:bodyPr lIns="45718" tIns="45718" rIns="45718" bIns="45718">
             <a:spAutoFit/>
           </a:bodyPr>
           <a:lstStyle>
@@ -2937,8 +2922,8 @@
         </p:nvSpPr>
         <p:spPr>
           <a:xfrm>
-            <a:off x="222477" y="1141163"/>
-            <a:ext cx="7786305" cy="666761"/>
+            <a:off x="222476" y="1141164"/>
+            <a:ext cx="7786307" cy="666758"/>
           </a:xfrm>
           <a:prstGeom prst="rect">
             <a:avLst/>
@@ -2953,7 +2938,7 @@
           </a:extLst>
         </p:spPr>
         <p:txBody>
-          <a:bodyPr lIns="45719" rIns="45719">
+          <a:bodyPr lIns="45718" tIns="45718" rIns="45718" bIns="45718">
             <a:spAutoFit/>
           </a:bodyPr>
           <a:lstStyle>
@@ -2986,7 +2971,7 @@
         <p:spPr>
           <a:xfrm>
             <a:off x="531891" y="1856172"/>
-            <a:ext cx="10972311" cy="544077"/>
+            <a:ext cx="10972311" cy="544075"/>
           </a:xfrm>
           <a:prstGeom prst="rect">
             <a:avLst/>
@@ -3001,27 +2986,23 @@
           </a:extLst>
         </p:spPr>
         <p:txBody>
-          <a:bodyPr lIns="45719" rIns="45719">
+          <a:bodyPr lIns="45718" tIns="45718" rIns="45718" bIns="45718">
             <a:spAutoFit/>
           </a:bodyPr>
-          <a:lstStyle/>
-          <a:p>
-            <a:pPr>
+          <a:lstStyle>
+            <a:lvl1pPr>
               <a:defRPr b="1" sz="3200">
                 <a:latin typeface="Times New Roman"/>
                 <a:ea typeface="Times New Roman"/>
                 <a:cs typeface="Times New Roman"/>
                 <a:sym typeface="Times New Roman"/>
               </a:defRPr>
-            </a:pPr>
-            <a:r>
-              <a:t>Names of sailors who have booked boats within 2019</a:t>
-            </a:r>
-            <a:r>
-              <a:t> </a:t>
-            </a:r>
-            <a:r>
-              <a:t>(2)</a:t>
+            </a:lvl1pPr>
+          </a:lstStyle>
+          <a:p>
+            <a:pPr/>
+            <a:r>
+              <a:t>Names of sailors who have booked red boats</a:t>
             </a:r>
           </a:p>
         </p:txBody>
@@ -3060,8 +3041,8 @@
         </p:nvSpPr>
         <p:spPr>
           <a:xfrm>
-            <a:off x="531892" y="205503"/>
-            <a:ext cx="10882867" cy="935370"/>
+            <a:off x="531891" y="205503"/>
+            <a:ext cx="10882869" cy="935369"/>
           </a:xfrm>
           <a:prstGeom prst="rect">
             <a:avLst/>
@@ -3076,7 +3057,7 @@
           </a:extLst>
         </p:spPr>
         <p:txBody>
-          <a:bodyPr lIns="45719" rIns="45719">
+          <a:bodyPr lIns="45718" tIns="45718" rIns="45718" bIns="45718">
             <a:spAutoFit/>
           </a:bodyPr>
           <a:lstStyle>
@@ -3108,8 +3089,8 @@
         </p:nvSpPr>
         <p:spPr>
           <a:xfrm>
-            <a:off x="222477" y="1141163"/>
-            <a:ext cx="7786305" cy="666761"/>
+            <a:off x="222476" y="1141164"/>
+            <a:ext cx="7786307" cy="666758"/>
           </a:xfrm>
           <a:prstGeom prst="rect">
             <a:avLst/>
@@ -3124,7 +3105,7 @@
           </a:extLst>
         </p:spPr>
         <p:txBody>
-          <a:bodyPr lIns="45719" rIns="45719">
+          <a:bodyPr lIns="45718" tIns="45718" rIns="45718" bIns="45718">
             <a:spAutoFit/>
           </a:bodyPr>
           <a:lstStyle>
@@ -3156,8 +3137,8 @@
         </p:nvSpPr>
         <p:spPr>
           <a:xfrm>
-            <a:off x="531891" y="1856172"/>
-            <a:ext cx="9826779" cy="544077"/>
+            <a:off x="531890" y="1856172"/>
+            <a:ext cx="9826781" cy="544075"/>
           </a:xfrm>
           <a:prstGeom prst="rect">
             <a:avLst/>
@@ -3172,7 +3153,7 @@
           </a:extLst>
         </p:spPr>
         <p:txBody>
-          <a:bodyPr lIns="45719" rIns="45719">
+          <a:bodyPr lIns="45718" tIns="45718" rIns="45718" bIns="45718">
             <a:spAutoFit/>
           </a:bodyPr>
           <a:lstStyle>
@@ -3227,8 +3208,8 @@
         </p:nvSpPr>
         <p:spPr>
           <a:xfrm>
-            <a:off x="860683" y="1560091"/>
-            <a:ext cx="11020854" cy="2156928"/>
+            <a:off x="860682" y="1560091"/>
+            <a:ext cx="11020856" cy="2156926"/>
           </a:xfrm>
           <a:prstGeom prst="rect">
             <a:avLst/>
@@ -3243,7 +3224,7 @@
           </a:extLst>
         </p:spPr>
         <p:txBody>
-          <a:bodyPr lIns="45719" rIns="45719">
+          <a:bodyPr lIns="45718" tIns="45718" rIns="45718" bIns="45718">
             <a:spAutoFit/>
           </a:bodyPr>
           <a:lstStyle/>
@@ -3303,8 +3284,8 @@
         </p:nvSpPr>
         <p:spPr>
           <a:xfrm>
-            <a:off x="860683" y="452095"/>
-            <a:ext cx="10470635" cy="1021034"/>
+            <a:off x="860682" y="452095"/>
+            <a:ext cx="10470637" cy="1021032"/>
           </a:xfrm>
           <a:prstGeom prst="rect">
             <a:avLst/>
@@ -3319,7 +3300,7 @@
           </a:extLst>
         </p:spPr>
         <p:txBody>
-          <a:bodyPr lIns="45719" rIns="45719">
+          <a:bodyPr lIns="45718" tIns="45718" rIns="45718" bIns="45718">
             <a:spAutoFit/>
           </a:bodyPr>
           <a:lstStyle>
@@ -3389,7 +3370,7 @@
         <p:spPr>
           <a:xfrm>
             <a:off x="531893" y="205503"/>
-            <a:ext cx="7748239" cy="935370"/>
+            <a:ext cx="7748238" cy="935369"/>
           </a:xfrm>
           <a:prstGeom prst="rect">
             <a:avLst/>
@@ -3404,7 +3385,7 @@
           </a:extLst>
         </p:spPr>
         <p:txBody>
-          <a:bodyPr lIns="45719" rIns="45719">
+          <a:bodyPr lIns="45718" tIns="45718" rIns="45718" bIns="45718">
             <a:spAutoFit/>
           </a:bodyPr>
           <a:lstStyle>
@@ -3436,8 +3417,8 @@
         </p:nvSpPr>
         <p:spPr>
           <a:xfrm>
-            <a:off x="531892" y="2236828"/>
-            <a:ext cx="11343067" cy="2514735"/>
+            <a:off x="531891" y="2236828"/>
+            <a:ext cx="11343069" cy="2108333"/>
           </a:xfrm>
           <a:prstGeom prst="rect">
             <a:avLst/>
@@ -3452,7 +3433,7 @@
           </a:extLst>
         </p:spPr>
         <p:txBody>
-          <a:bodyPr lIns="45719" rIns="45719">
+          <a:bodyPr lIns="45718" tIns="45718" rIns="45718" bIns="45718">
             <a:spAutoFit/>
           </a:bodyPr>
           <a:lstStyle/>
@@ -3533,8 +3514,8 @@
         </p:nvSpPr>
         <p:spPr>
           <a:xfrm>
-            <a:off x="531892" y="1221165"/>
-            <a:ext cx="5001083" cy="666761"/>
+            <a:off x="531891" y="1221165"/>
+            <a:ext cx="5001081" cy="666759"/>
           </a:xfrm>
           <a:prstGeom prst="rect">
             <a:avLst/>
@@ -3549,7 +3530,7 @@
           </a:extLst>
         </p:spPr>
         <p:txBody>
-          <a:bodyPr wrap="none" lIns="45719" rIns="45719">
+          <a:bodyPr wrap="none" lIns="45718" tIns="45718" rIns="45718" bIns="45718">
             <a:spAutoFit/>
           </a:bodyPr>
           <a:lstStyle>
@@ -3608,7 +3589,7 @@
         <p:spPr>
           <a:xfrm>
             <a:off x="531893" y="205503"/>
-            <a:ext cx="7748239" cy="935370"/>
+            <a:ext cx="7748238" cy="935369"/>
           </a:xfrm>
           <a:prstGeom prst="rect">
             <a:avLst/>
@@ -3623,7 +3604,7 @@
           </a:extLst>
         </p:spPr>
         <p:txBody>
-          <a:bodyPr lIns="45719" rIns="45719">
+          <a:bodyPr lIns="45718" tIns="45718" rIns="45718" bIns="45718">
             <a:spAutoFit/>
           </a:bodyPr>
           <a:lstStyle>
@@ -3655,8 +3636,8 @@
         </p:nvSpPr>
         <p:spPr>
           <a:xfrm>
-            <a:off x="531892" y="1221165"/>
-            <a:ext cx="5001083" cy="666761"/>
+            <a:off x="531891" y="1221165"/>
+            <a:ext cx="5001081" cy="666759"/>
           </a:xfrm>
           <a:prstGeom prst="rect">
             <a:avLst/>
@@ -3671,7 +3652,7 @@
           </a:extLst>
         </p:spPr>
         <p:txBody>
-          <a:bodyPr wrap="none" lIns="45719" rIns="45719">
+          <a:bodyPr wrap="none" lIns="45718" tIns="45718" rIns="45718" bIns="45718">
             <a:spAutoFit/>
           </a:bodyPr>
           <a:lstStyle>
@@ -3703,8 +3684,8 @@
         </p:nvSpPr>
         <p:spPr>
           <a:xfrm>
-            <a:off x="517080" y="2753669"/>
-            <a:ext cx="11157839" cy="3558355"/>
+            <a:off x="517079" y="2753668"/>
+            <a:ext cx="11157841" cy="3558353"/>
           </a:xfrm>
           <a:prstGeom prst="rect">
             <a:avLst/>
@@ -3724,7 +3705,7 @@
           </a:extLst>
         </p:spPr>
         <p:txBody>
-          <a:bodyPr lIns="45719" rIns="45719">
+          <a:bodyPr lIns="45718" tIns="45718" rIns="45718" bIns="45718">
             <a:spAutoFit/>
           </a:bodyPr>
           <a:lstStyle/>
@@ -3888,8 +3869,8 @@
         </p:nvSpPr>
         <p:spPr>
           <a:xfrm>
-            <a:off x="531891" y="2024359"/>
-            <a:ext cx="11343067" cy="482735"/>
+            <a:off x="531890" y="2024359"/>
+            <a:ext cx="11343069" cy="482733"/>
           </a:xfrm>
           <a:prstGeom prst="rect">
             <a:avLst/>
@@ -3904,11 +3885,11 @@
           </a:extLst>
         </p:spPr>
         <p:txBody>
-          <a:bodyPr lIns="45719" rIns="45719">
+          <a:bodyPr lIns="45718" tIns="45718" rIns="45718" bIns="45718">
             <a:spAutoFit/>
           </a:bodyPr>
           <a:lstStyle>
-            <a:lvl1pPr marL="742949" indent="-742949" algn="just">
+            <a:lvl1pPr marL="742948" indent="-742948" algn="just">
               <a:buSzPct val="100000"/>
               <a:buAutoNum type="arabicPeriod" startAt="3"/>
               <a:defRPr sz="2800">
@@ -3962,7 +3943,7 @@
         <p:spPr>
           <a:xfrm>
             <a:off x="531893" y="205503"/>
-            <a:ext cx="7748239" cy="935370"/>
+            <a:ext cx="7748238" cy="935369"/>
           </a:xfrm>
           <a:prstGeom prst="rect">
             <a:avLst/>
@@ -3977,7 +3958,7 @@
           </a:extLst>
         </p:spPr>
         <p:txBody>
-          <a:bodyPr lIns="45719" rIns="45719">
+          <a:bodyPr lIns="45718" tIns="45718" rIns="45718" bIns="45718">
             <a:spAutoFit/>
           </a:bodyPr>
           <a:lstStyle>
@@ -4009,8 +3990,8 @@
         </p:nvSpPr>
         <p:spPr>
           <a:xfrm>
-            <a:off x="531892" y="1221165"/>
-            <a:ext cx="5001083" cy="666761"/>
+            <a:off x="531891" y="1221165"/>
+            <a:ext cx="5001081" cy="666759"/>
           </a:xfrm>
           <a:prstGeom prst="rect">
             <a:avLst/>
@@ -4025,7 +4006,7 @@
           </a:extLst>
         </p:spPr>
         <p:txBody>
-          <a:bodyPr wrap="none" lIns="45719" rIns="45719">
+          <a:bodyPr wrap="none" lIns="45718" tIns="45718" rIns="45718" bIns="45718">
             <a:spAutoFit/>
           </a:bodyPr>
           <a:lstStyle>
@@ -4057,8 +4038,8 @@
         </p:nvSpPr>
         <p:spPr>
           <a:xfrm>
-            <a:off x="566245" y="2642887"/>
-            <a:ext cx="11274357" cy="3825055"/>
+            <a:off x="566245" y="2642886"/>
+            <a:ext cx="11274357" cy="3825053"/>
           </a:xfrm>
           <a:prstGeom prst="rect">
             <a:avLst/>
@@ -4078,7 +4059,7 @@
           </a:extLst>
         </p:spPr>
         <p:txBody>
-          <a:bodyPr lIns="45719" rIns="45719">
+          <a:bodyPr lIns="45718" tIns="45718" rIns="45718" bIns="45718">
             <a:spAutoFit/>
           </a:bodyPr>
           <a:lstStyle/>
@@ -4242,8 +4223,8 @@
         </p:nvSpPr>
         <p:spPr>
           <a:xfrm>
-            <a:off x="531891" y="2024359"/>
-            <a:ext cx="11343067" cy="482735"/>
+            <a:off x="531890" y="2024359"/>
+            <a:ext cx="11343069" cy="482733"/>
           </a:xfrm>
           <a:prstGeom prst="rect">
             <a:avLst/>
@@ -4258,11 +4239,11 @@
           </a:extLst>
         </p:spPr>
         <p:txBody>
-          <a:bodyPr lIns="45719" rIns="45719">
+          <a:bodyPr lIns="45718" tIns="45718" rIns="45718" bIns="45718">
             <a:spAutoFit/>
           </a:bodyPr>
           <a:lstStyle>
-            <a:lvl1pPr marL="742949" indent="-742949" algn="just">
+            <a:lvl1pPr marL="742948" indent="-742948" algn="just">
               <a:buSzPct val="100000"/>
               <a:buAutoNum type="arabicPeriod" startAt="3"/>
               <a:defRPr sz="2800">
@@ -4316,7 +4297,7 @@
         <p:spPr>
           <a:xfrm>
             <a:off x="531893" y="205503"/>
-            <a:ext cx="7748239" cy="935370"/>
+            <a:ext cx="7748238" cy="935369"/>
           </a:xfrm>
           <a:prstGeom prst="rect">
             <a:avLst/>
@@ -4331,7 +4312,7 @@
           </a:extLst>
         </p:spPr>
         <p:txBody>
-          <a:bodyPr lIns="45719" rIns="45719">
+          <a:bodyPr lIns="45718" tIns="45718" rIns="45718" bIns="45718">
             <a:spAutoFit/>
           </a:bodyPr>
           <a:lstStyle>
@@ -4363,8 +4344,8 @@
         </p:nvSpPr>
         <p:spPr>
           <a:xfrm>
-            <a:off x="531892" y="1221165"/>
-            <a:ext cx="5001083" cy="666761"/>
+            <a:off x="531891" y="1221165"/>
+            <a:ext cx="5001081" cy="666759"/>
           </a:xfrm>
           <a:prstGeom prst="rect">
             <a:avLst/>
@@ -4379,7 +4360,7 @@
           </a:extLst>
         </p:spPr>
         <p:txBody>
-          <a:bodyPr wrap="none" lIns="45719" rIns="45719">
+          <a:bodyPr wrap="none" lIns="45718" tIns="45718" rIns="45718" bIns="45718">
             <a:spAutoFit/>
           </a:bodyPr>
           <a:lstStyle>
@@ -4411,8 +4392,8 @@
         </p:nvSpPr>
         <p:spPr>
           <a:xfrm>
-            <a:off x="294921" y="2642887"/>
-            <a:ext cx="11625757" cy="2831218"/>
+            <a:off x="294920" y="2642886"/>
+            <a:ext cx="11625759" cy="2831216"/>
           </a:xfrm>
           <a:prstGeom prst="rect">
             <a:avLst/>
@@ -4432,7 +4413,7 @@
           </a:extLst>
         </p:spPr>
         <p:txBody>
-          <a:bodyPr lIns="45719" rIns="45719">
+          <a:bodyPr lIns="45718" tIns="45718" rIns="45718" bIns="45718">
             <a:spAutoFit/>
           </a:bodyPr>
           <a:lstStyle/>
@@ -4727,8 +4708,8 @@
         </p:nvSpPr>
         <p:spPr>
           <a:xfrm>
-            <a:off x="531891" y="2024359"/>
-            <a:ext cx="11343067" cy="482735"/>
+            <a:off x="531890" y="2024359"/>
+            <a:ext cx="11343069" cy="482733"/>
           </a:xfrm>
           <a:prstGeom prst="rect">
             <a:avLst/>
@@ -4743,11 +4724,11 @@
           </a:extLst>
         </p:spPr>
         <p:txBody>
-          <a:bodyPr lIns="45719" rIns="45719">
+          <a:bodyPr lIns="45718" tIns="45718" rIns="45718" bIns="45718">
             <a:spAutoFit/>
           </a:bodyPr>
           <a:lstStyle>
-            <a:lvl1pPr marL="742949" indent="-742949" algn="just">
+            <a:lvl1pPr marL="742948" indent="-742948" algn="just">
               <a:buSzPct val="100000"/>
               <a:buAutoNum type="arabicPeriod" startAt="4"/>
               <a:defRPr sz="2800">
@@ -4801,7 +4782,7 @@
         <p:spPr>
           <a:xfrm>
             <a:off x="531893" y="205503"/>
-            <a:ext cx="7748239" cy="935370"/>
+            <a:ext cx="7748238" cy="935369"/>
           </a:xfrm>
           <a:prstGeom prst="rect">
             <a:avLst/>
@@ -4816,7 +4797,7 @@
           </a:extLst>
         </p:spPr>
         <p:txBody>
-          <a:bodyPr lIns="45719" rIns="45719">
+          <a:bodyPr lIns="45718" tIns="45718" rIns="45718" bIns="45718">
             <a:spAutoFit/>
           </a:bodyPr>
           <a:lstStyle>
@@ -4848,8 +4829,8 @@
         </p:nvSpPr>
         <p:spPr>
           <a:xfrm>
-            <a:off x="531892" y="1221165"/>
-            <a:ext cx="5001083" cy="666761"/>
+            <a:off x="531891" y="1221165"/>
+            <a:ext cx="5001081" cy="666759"/>
           </a:xfrm>
           <a:prstGeom prst="rect">
             <a:avLst/>
@@ -4864,7 +4845,7 @@
           </a:extLst>
         </p:spPr>
         <p:txBody>
-          <a:bodyPr wrap="none" lIns="45719" rIns="45719">
+          <a:bodyPr wrap="none" lIns="45718" tIns="45718" rIns="45718" bIns="45718">
             <a:spAutoFit/>
           </a:bodyPr>
           <a:lstStyle>
@@ -4896,8 +4877,8 @@
         </p:nvSpPr>
         <p:spPr>
           <a:xfrm>
-            <a:off x="690040" y="2620623"/>
-            <a:ext cx="11230638" cy="3148718"/>
+            <a:off x="690039" y="2620622"/>
+            <a:ext cx="11230640" cy="3148716"/>
           </a:xfrm>
           <a:prstGeom prst="rect">
             <a:avLst/>
@@ -4917,7 +4898,7 @@
           </a:extLst>
         </p:spPr>
         <p:txBody>
-          <a:bodyPr lIns="45719" rIns="45719">
+          <a:bodyPr lIns="45718" tIns="45718" rIns="45718" bIns="45718">
             <a:spAutoFit/>
           </a:bodyPr>
           <a:lstStyle/>
@@ -4950,6 +4931,7 @@
           <a:p>
             <a:pPr lvl="4" marL="2286000" indent="-457200">
               <a:buSzPct val="100000"/>
+              <a:buFont typeface="Times New Roman"/>
               <a:buChar char="➢"/>
               <a:defRPr b="1" sz="2400">
                 <a:latin typeface="Times New Roman"/>
@@ -4965,6 +4947,7 @@
           <a:p>
             <a:pPr lvl="4" marL="2286000" indent="-457200">
               <a:buSzPct val="100000"/>
+              <a:buFont typeface="Times New Roman"/>
               <a:buChar char="➢"/>
               <a:defRPr b="1" sz="2400">
                 <a:latin typeface="Times New Roman"/>
@@ -4980,6 +4963,7 @@
           <a:p>
             <a:pPr lvl="4" marL="2286000" indent="-457200">
               <a:buSzPct val="100000"/>
+              <a:buFont typeface="Times New Roman"/>
               <a:buChar char="➢"/>
               <a:defRPr b="1" sz="2400">
                 <a:latin typeface="Times New Roman"/>
@@ -4995,6 +4979,7 @@
           <a:p>
             <a:pPr lvl="4" marL="2286000" indent="-457200">
               <a:buSzPct val="100000"/>
+              <a:buFont typeface="Times New Roman"/>
               <a:buChar char="➢"/>
               <a:defRPr b="1" sz="2400">
                 <a:latin typeface="Times New Roman"/>
@@ -5010,6 +4995,7 @@
           <a:p>
             <a:pPr lvl="4" marL="2286000" indent="-457200">
               <a:buSzPct val="100000"/>
+              <a:buFont typeface="Times New Roman"/>
               <a:buChar char="➢"/>
               <a:defRPr b="1" sz="2400">
                 <a:latin typeface="Times New Roman"/>
@@ -5025,6 +5011,7 @@
           <a:p>
             <a:pPr lvl="4" marL="2286000" indent="-457200">
               <a:buSzPct val="100000"/>
+              <a:buFont typeface="Times New Roman"/>
               <a:buChar char="➢"/>
               <a:defRPr b="1" sz="2400">
                 <a:latin typeface="Times New Roman"/>
@@ -5040,6 +5027,7 @@
           <a:p>
             <a:pPr lvl="4" marL="2286000" indent="-457200">
               <a:buSzPct val="100000"/>
+              <a:buFont typeface="Times New Roman"/>
               <a:buChar char="➢"/>
               <a:defRPr b="1" sz="2400">
                 <a:latin typeface="Times New Roman"/>
@@ -5062,8 +5050,8 @@
         </p:nvSpPr>
         <p:spPr>
           <a:xfrm>
-            <a:off x="531891" y="2024359"/>
-            <a:ext cx="11343067" cy="482735"/>
+            <a:off x="531890" y="2024359"/>
+            <a:ext cx="11343069" cy="482733"/>
           </a:xfrm>
           <a:prstGeom prst="rect">
             <a:avLst/>
@@ -5078,11 +5066,11 @@
           </a:extLst>
         </p:spPr>
         <p:txBody>
-          <a:bodyPr lIns="45719" rIns="45719">
+          <a:bodyPr lIns="45718" tIns="45718" rIns="45718" bIns="45718">
             <a:spAutoFit/>
           </a:bodyPr>
           <a:lstStyle>
-            <a:lvl1pPr marL="742949" indent="-742949" algn="just">
+            <a:lvl1pPr marL="742948" indent="-742948" algn="just">
               <a:buSzPct val="100000"/>
               <a:buAutoNum type="arabicPeriod" startAt="5"/>
               <a:defRPr sz="2800">
@@ -5110,7 +5098,7 @@
         <p:spPr>
           <a:xfrm>
             <a:off x="6171281" y="4873761"/>
-            <a:ext cx="4720617" cy="891355"/>
+            <a:ext cx="4720618" cy="891353"/>
           </a:xfrm>
           <a:prstGeom prst="rect">
             <a:avLst/>
@@ -5127,7 +5115,7 @@
           </a:extLst>
         </p:spPr>
         <p:txBody>
-          <a:bodyPr lIns="45719" rIns="45719">
+          <a:bodyPr lIns="45718" tIns="45718" rIns="45718" bIns="45718">
             <a:spAutoFit/>
           </a:bodyPr>
           <a:lstStyle/>
@@ -5192,7 +5180,7 @@
         <p:spPr>
           <a:xfrm>
             <a:off x="531893" y="205503"/>
-            <a:ext cx="7748239" cy="935370"/>
+            <a:ext cx="7748238" cy="935369"/>
           </a:xfrm>
           <a:prstGeom prst="rect">
             <a:avLst/>
@@ -5207,7 +5195,7 @@
           </a:extLst>
         </p:spPr>
         <p:txBody>
-          <a:bodyPr lIns="45719" rIns="45719">
+          <a:bodyPr lIns="45718" tIns="45718" rIns="45718" bIns="45718">
             <a:spAutoFit/>
           </a:bodyPr>
           <a:lstStyle>
@@ -5239,8 +5227,8 @@
         </p:nvSpPr>
         <p:spPr>
           <a:xfrm>
-            <a:off x="229490" y="2133330"/>
-            <a:ext cx="11343067" cy="3164593"/>
+            <a:off x="229489" y="2133331"/>
+            <a:ext cx="11343069" cy="3164590"/>
           </a:xfrm>
           <a:prstGeom prst="rect">
             <a:avLst/>
@@ -5255,7 +5243,7 @@
           </a:extLst>
         </p:spPr>
         <p:txBody>
-          <a:bodyPr lIns="45719" rIns="45719">
+          <a:bodyPr lIns="45718" tIns="45718" rIns="45718" bIns="45718">
             <a:spAutoFit/>
           </a:bodyPr>
           <a:lstStyle/>
@@ -5376,8 +5364,8 @@
         </p:nvSpPr>
         <p:spPr>
           <a:xfrm>
-            <a:off x="531893" y="1221165"/>
-            <a:ext cx="5127090" cy="666761"/>
+            <a:off x="531892" y="1221165"/>
+            <a:ext cx="5127089" cy="666759"/>
           </a:xfrm>
           <a:prstGeom prst="rect">
             <a:avLst/>
@@ -5392,7 +5380,7 @@
           </a:extLst>
         </p:spPr>
         <p:txBody>
-          <a:bodyPr wrap="none" lIns="45719" rIns="45719">
+          <a:bodyPr wrap="none" lIns="45718" tIns="45718" rIns="45718" bIns="45718">
             <a:spAutoFit/>
           </a:bodyPr>
           <a:lstStyle>
@@ -5451,7 +5439,7 @@
         <p:spPr>
           <a:xfrm>
             <a:off x="531893" y="205503"/>
-            <a:ext cx="7748239" cy="935370"/>
+            <a:ext cx="7748238" cy="935369"/>
           </a:xfrm>
           <a:prstGeom prst="rect">
             <a:avLst/>
@@ -5466,7 +5454,7 @@
           </a:extLst>
         </p:spPr>
         <p:txBody>
-          <a:bodyPr lIns="45719" rIns="45719">
+          <a:bodyPr lIns="45718" tIns="45718" rIns="45718" bIns="45718">
             <a:spAutoFit/>
           </a:bodyPr>
           <a:lstStyle>
@@ -5498,8 +5486,8 @@
         </p:nvSpPr>
         <p:spPr>
           <a:xfrm>
-            <a:off x="232114" y="1929052"/>
-            <a:ext cx="11727772" cy="4803637"/>
+            <a:off x="232113" y="1929053"/>
+            <a:ext cx="11727774" cy="4803635"/>
           </a:xfrm>
           <a:prstGeom prst="rect">
             <a:avLst/>
@@ -5514,7 +5502,7 @@
           </a:extLst>
         </p:spPr>
         <p:txBody>
-          <a:bodyPr lIns="45719" rIns="45719">
+          <a:bodyPr lIns="45718" tIns="45718" rIns="45718" bIns="45718">
             <a:spAutoFit/>
           </a:bodyPr>
           <a:lstStyle/>
@@ -5601,7 +5589,7 @@
             </a:r>
           </a:p>
           <a:p>
-            <a:pPr lvl="1">
+            <a:pPr lvl="1" indent="457200">
               <a:defRPr sz="2400">
                 <a:latin typeface="Times New Roman"/>
                 <a:ea typeface="Times New Roman"/>
@@ -5625,9 +5613,9 @@
                 <a:solidFill>
                   <a:srgbClr val="33339B"/>
                 </a:solidFill>
-                <a:latin typeface="+mn-lt"/>
-                <a:ea typeface="+mn-ea"/>
-                <a:cs typeface="+mn-cs"/>
+                <a:latin typeface="+mj-lt"/>
+                <a:ea typeface="+mj-ea"/>
+                <a:cs typeface="+mj-cs"/>
                 <a:sym typeface="Helvetica"/>
               </a:rPr>
               <a:t>：</a:t>
@@ -5639,7 +5627,7 @@
             </a:endParaRPr>
           </a:p>
           <a:p>
-            <a:pPr lvl="1">
+            <a:pPr lvl="1" indent="457200">
               <a:defRPr sz="2400">
                 <a:solidFill>
                   <a:srgbClr val="33339B"/>
@@ -5655,16 +5643,16 @@
             </a:r>
             <a:r>
               <a:rPr>
-                <a:latin typeface="+mn-lt"/>
-                <a:ea typeface="+mn-ea"/>
-                <a:cs typeface="+mn-cs"/>
+                <a:latin typeface="+mj-lt"/>
+                <a:ea typeface="+mj-ea"/>
+                <a:cs typeface="+mj-cs"/>
                 <a:sym typeface="Helvetica"/>
               </a:rPr>
               <a:t>：</a:t>
             </a:r>
           </a:p>
           <a:p>
-            <a:pPr lvl="1">
+            <a:pPr lvl="1" indent="457200">
               <a:defRPr sz="2400">
                 <a:solidFill>
                   <a:srgbClr val="33339B"/>
@@ -5680,7 +5668,7 @@
             </a:r>
           </a:p>
           <a:p>
-            <a:pPr lvl="1">
+            <a:pPr lvl="1" indent="457200">
               <a:defRPr sz="2400">
                 <a:solidFill>
                   <a:srgbClr val="33339B"/>
@@ -5696,9 +5684,9 @@
             </a:r>
             <a:r>
               <a:rPr>
-                <a:latin typeface="+mn-lt"/>
-                <a:ea typeface="+mn-ea"/>
-                <a:cs typeface="+mn-cs"/>
+                <a:latin typeface="+mj-lt"/>
+                <a:ea typeface="+mj-ea"/>
+                <a:cs typeface="+mj-cs"/>
                 <a:sym typeface="Helvetica"/>
               </a:rPr>
               <a:t>：</a:t>
@@ -5781,8 +5769,8 @@
         </p:nvSpPr>
         <p:spPr>
           <a:xfrm>
-            <a:off x="531893" y="1221165"/>
-            <a:ext cx="5127090" cy="666761"/>
+            <a:off x="531892" y="1221165"/>
+            <a:ext cx="5127089" cy="666759"/>
           </a:xfrm>
           <a:prstGeom prst="rect">
             <a:avLst/>
@@ -5797,7 +5785,7 @@
           </a:extLst>
         </p:spPr>
         <p:txBody>
-          <a:bodyPr wrap="none" lIns="45719" rIns="45719">
+          <a:bodyPr wrap="none" lIns="45718" tIns="45718" rIns="45718" bIns="45718">
             <a:spAutoFit/>
           </a:bodyPr>
           <a:lstStyle>
@@ -5855,8 +5843,8 @@
         </p:nvSpPr>
         <p:spPr>
           <a:xfrm>
-            <a:off x="592132" y="378536"/>
-            <a:ext cx="10371469" cy="666761"/>
+            <a:off x="592131" y="378537"/>
+            <a:ext cx="10371471" cy="666758"/>
           </a:xfrm>
           <a:prstGeom prst="rect">
             <a:avLst/>
@@ -5871,7 +5859,7 @@
           </a:extLst>
         </p:spPr>
         <p:txBody>
-          <a:bodyPr lIns="45719" rIns="45719">
+          <a:bodyPr lIns="45718" tIns="45718" rIns="45718" bIns="45718">
             <a:spAutoFit/>
           </a:bodyPr>
           <a:lstStyle>
@@ -5903,8 +5891,8 @@
         </p:nvSpPr>
         <p:spPr>
           <a:xfrm>
-            <a:off x="1268926" y="6088558"/>
-            <a:ext cx="9286389" cy="724928"/>
+            <a:off x="1268926" y="6088557"/>
+            <a:ext cx="9286387" cy="724926"/>
           </a:xfrm>
           <a:prstGeom prst="rect">
             <a:avLst/>
@@ -5921,12 +5909,11 @@
           </a:extLst>
         </p:spPr>
         <p:txBody>
-          <a:bodyPr wrap="none" lIns="45719" rIns="45719">
+          <a:bodyPr wrap="none" lIns="45718" tIns="45718" rIns="45718" bIns="45718">
             <a:spAutoFit/>
           </a:bodyPr>
-          <a:lstStyle/>
-          <a:p>
-            <a:pPr>
+          <a:lstStyle>
+            <a:lvl1pPr>
               <a:defRPr b="1" sz="4400">
                 <a:solidFill>
                   <a:srgbClr val="C00000"/>
@@ -5936,15 +5923,12 @@
                 <a:cs typeface="Times New Roman"/>
                 <a:sym typeface="Times New Roman"/>
               </a:defRPr>
-            </a:pPr>
-            <a:r>
-              <a:t>Deadline:</a:t>
-            </a:r>
-            <a:r>
-              <a:t> </a:t>
-            </a:r>
-            <a:r>
-              <a:t>Beijing time, 11.01, 23:59:59</a:t>
+            </a:lvl1pPr>
+          </a:lstStyle>
+          <a:p>
+            <a:pPr/>
+            <a:r>
+              <a:t>Deadline: Beijing time, 11.01, 23:59:59</a:t>
             </a:r>
           </a:p>
         </p:txBody>
@@ -5954,13 +5938,13 @@
           <p:cNvPr id="100" name="灯片编号占位符 2"/>
           <p:cNvSpPr txBox="1"/>
           <p:nvPr>
-            <p:ph type="sldNum" sz="quarter" idx="2"/>
+            <p:ph type="sldNum" sz="quarter" idx="4294967295"/>
           </p:nvPr>
         </p:nvSpPr>
         <p:spPr>
           <a:xfrm>
-            <a:off x="11172418" y="6414762"/>
-            <a:ext cx="181383" cy="248305"/>
+            <a:off x="11172418" y="6414761"/>
+            <a:ext cx="181380" cy="248304"/>
           </a:xfrm>
           <a:prstGeom prst="rect">
             <a:avLst/>
@@ -5988,8 +5972,8 @@
         </p:nvSpPr>
         <p:spPr>
           <a:xfrm>
-            <a:off x="592130" y="1082975"/>
-            <a:ext cx="10371472" cy="4957724"/>
+            <a:off x="592129" y="1082975"/>
+            <a:ext cx="10371474" cy="4957722"/>
           </a:xfrm>
           <a:prstGeom prst="rect">
             <a:avLst/>
@@ -6004,7 +5988,7 @@
           </a:extLst>
         </p:spPr>
         <p:txBody>
-          <a:bodyPr lIns="45719" rIns="45719">
+          <a:bodyPr lIns="45718" tIns="45718" rIns="45718" bIns="45718">
             <a:spAutoFit/>
           </a:bodyPr>
           <a:lstStyle/>
@@ -6029,11 +6013,11 @@
             <a:r>
               <a:rPr u="sng">
                 <a:solidFill>
-                  <a:srgbClr val="0563C1"/>
+                  <a:srgbClr val="0000FF"/>
                 </a:solidFill>
                 <a:uFill>
                   <a:solidFill>
-                    <a:srgbClr val="0563C1"/>
+                    <a:srgbClr val="0000FF"/>
                   </a:solidFill>
                 </a:uFill>
                 <a:hlinkClick r:id="rId2" invalidUrl="" action="" tgtFrame="" tooltip="" history="1" highlightClick="0" endSnd="0"/>
@@ -6091,7 +6075,7 @@
             </a:endParaRPr>
           </a:p>
           <a:p>
-            <a:pPr lvl="1">
+            <a:pPr lvl="1" indent="457200">
               <a:lnSpc>
                 <a:spcPct val="150000"/>
               </a:lnSpc>
@@ -6127,31 +6111,7 @@
                 <a:cs typeface="微软雅黑"/>
                 <a:sym typeface="微软雅黑"/>
               </a:rPr>
-              <a:t>71121000-</a:t>
-            </a:r>
-            <a:r>
-              <a:rPr i="1">
-                <a:solidFill>
-                  <a:srgbClr val="33339B"/>
-                </a:solidFill>
-                <a:latin typeface="微软雅黑"/>
-                <a:ea typeface="微软雅黑"/>
-                <a:cs typeface="微软雅黑"/>
-                <a:sym typeface="微软雅黑"/>
-              </a:rPr>
-              <a:t>张三</a:t>
-            </a:r>
-            <a:r>
-              <a:rPr i="1">
-                <a:solidFill>
-                  <a:srgbClr val="33339B"/>
-                </a:solidFill>
-                <a:latin typeface="微软雅黑"/>
-                <a:ea typeface="微软雅黑"/>
-                <a:cs typeface="微软雅黑"/>
-                <a:sym typeface="微软雅黑"/>
-              </a:rPr>
-              <a:t>-Project-1.zip</a:t>
+              <a:t>71121000-张三-Project-1.zip</a:t>
             </a:r>
             <a:endParaRPr i="1">
               <a:solidFill>
@@ -6301,8 +6261,8 @@
         </p:nvSpPr>
         <p:spPr>
           <a:xfrm>
-            <a:off x="860683" y="1560091"/>
-            <a:ext cx="11020854" cy="4770052"/>
+            <a:off x="860682" y="1560091"/>
+            <a:ext cx="11020856" cy="4770050"/>
           </a:xfrm>
           <a:prstGeom prst="rect">
             <a:avLst/>
@@ -6317,7 +6277,7 @@
           </a:extLst>
         </p:spPr>
         <p:txBody>
-          <a:bodyPr lIns="45719" rIns="45719">
+          <a:bodyPr lIns="45718" tIns="45718" rIns="45718" bIns="45718">
             <a:spAutoFit/>
           </a:bodyPr>
           <a:lstStyle/>
@@ -6346,18 +6306,7 @@
               </a:lnSpc>
               <a:buSzPct val="100000"/>
               <a:buAutoNum type="romanUcPeriod" startAt="1"/>
-              <a:defRPr sz="6000">
-                <a:solidFill>
-                  <a:srgbClr val="808080"/>
-                </a:solidFill>
-                <a:latin typeface="Calibri Light"/>
-                <a:ea typeface="Calibri Light"/>
-                <a:cs typeface="Calibri Light"/>
-                <a:sym typeface="Calibri Light"/>
-              </a:defRPr>
-            </a:pPr>
-            <a:r>
-              <a:rPr u="sng">
+              <a:defRPr sz="6000" u="sng">
                 <a:solidFill>
                   <a:srgbClr val="0563C1"/>
                 </a:solidFill>
@@ -6366,10 +6315,31 @@
                     <a:srgbClr val="0563C1"/>
                   </a:solidFill>
                 </a:uFill>
+                <a:latin typeface="Calibri Light"/>
+                <a:ea typeface="Calibri Light"/>
+                <a:cs typeface="Calibri Light"/>
+                <a:sym typeface="Calibri Light"/>
+              </a:defRPr>
+            </a:pPr>
+            <a:r>
+              <a:rPr>
+                <a:solidFill>
+                  <a:srgbClr val="0000FF"/>
+                </a:solidFill>
+                <a:uFill>
+                  <a:solidFill>
+                    <a:srgbClr val="0000FF"/>
+                  </a:solidFill>
+                </a:uFill>
                 <a:hlinkClick r:id="rId2" invalidUrl="" action="" tgtFrame="" tooltip="" history="1" highlightClick="0" endSnd="0"/>
               </a:rPr>
               <a:t>nowcoder</a:t>
             </a:r>
+            <a:endParaRPr>
+              <a:solidFill>
+                <a:srgbClr val="808080"/>
+              </a:solidFill>
+            </a:endParaRPr>
           </a:p>
           <a:p>
             <a:pPr marL="1028700" indent="-1028700">
@@ -6378,10 +6348,7 @@
               </a:lnSpc>
               <a:buSzPct val="100000"/>
               <a:buAutoNum type="romanUcPeriod" startAt="1"/>
-              <a:defRPr sz="6000"/>
-            </a:pPr>
-            <a:r>
-              <a:rPr u="sng">
+              <a:defRPr sz="6000" u="sng">
                 <a:solidFill>
                   <a:srgbClr val="0563C1"/>
                 </a:solidFill>
@@ -6390,6 +6357,22 @@
                     <a:srgbClr val="0563C1"/>
                   </a:solidFill>
                 </a:uFill>
+                <a:latin typeface="Calibri"/>
+                <a:ea typeface="Calibri"/>
+                <a:cs typeface="Calibri"/>
+                <a:sym typeface="Calibri"/>
+              </a:defRPr>
+            </a:pPr>
+            <a:r>
+              <a:rPr>
+                <a:solidFill>
+                  <a:srgbClr val="0000FF"/>
+                </a:solidFill>
+                <a:uFill>
+                  <a:solidFill>
+                    <a:srgbClr val="0000FF"/>
+                  </a:solidFill>
+                </a:uFill>
                 <a:hlinkClick r:id="rId3" invalidUrl="" action="" tgtFrame="" tooltip="" history="1" highlightClick="0" endSnd="0"/>
               </a:rPr>
               <a:t>LeetCode</a:t>
@@ -6402,7 +6385,12 @@
               </a:lnSpc>
               <a:buSzPct val="100000"/>
               <a:buAutoNum type="romanUcPeriod" startAt="1"/>
-              <a:defRPr sz="6000"/>
+              <a:defRPr sz="6000">
+                <a:latin typeface="Calibri"/>
+                <a:ea typeface="Calibri"/>
+                <a:cs typeface="Calibri"/>
+                <a:sym typeface="Calibri"/>
+              </a:defRPr>
             </a:pPr>
             <a:r>
               <a:t>AI</a:t>
@@ -6418,8 +6406,8 @@
         </p:nvSpPr>
         <p:spPr>
           <a:xfrm>
-            <a:off x="860683" y="452096"/>
-            <a:ext cx="10470635" cy="2225041"/>
+            <a:off x="860682" y="452096"/>
+            <a:ext cx="10470637" cy="2225039"/>
           </a:xfrm>
           <a:prstGeom prst="rect">
             <a:avLst/>
@@ -6434,7 +6422,7 @@
           </a:extLst>
         </p:spPr>
         <p:txBody>
-          <a:bodyPr lIns="45719" rIns="45719">
+          <a:bodyPr lIns="45718" tIns="45718" rIns="45718" bIns="45718">
             <a:spAutoFit/>
           </a:bodyPr>
           <a:lstStyle/>
@@ -6471,9 +6459,9 @@
             </a:r>
             <a:r>
               <a:rPr>
-                <a:latin typeface="+mn-lt"/>
-                <a:ea typeface="+mn-ea"/>
-                <a:cs typeface="+mn-cs"/>
+                <a:latin typeface="+mj-lt"/>
+                <a:ea typeface="+mj-ea"/>
+                <a:cs typeface="+mj-cs"/>
                 <a:sym typeface="Helvetica"/>
               </a:rPr>
               <a:t>？</a:t>
@@ -6526,8 +6514,8 @@
         </p:nvSpPr>
         <p:spPr>
           <a:xfrm>
-            <a:off x="592132" y="147704"/>
-            <a:ext cx="10371469" cy="666761"/>
+            <a:off x="592131" y="147705"/>
+            <a:ext cx="10371471" cy="666758"/>
           </a:xfrm>
           <a:prstGeom prst="rect">
             <a:avLst/>
@@ -6542,7 +6530,7 @@
           </a:extLst>
         </p:spPr>
         <p:txBody>
-          <a:bodyPr lIns="45719" rIns="45719">
+          <a:bodyPr lIns="45718" tIns="45718" rIns="45718" bIns="45718">
             <a:spAutoFit/>
           </a:bodyPr>
           <a:lstStyle>
@@ -6574,8 +6562,8 @@
         </p:nvSpPr>
         <p:spPr>
           <a:xfrm>
-            <a:off x="185334" y="1261990"/>
-            <a:ext cx="11821332" cy="3774441"/>
+            <a:off x="185334" y="1261991"/>
+            <a:ext cx="11821332" cy="3774439"/>
           </a:xfrm>
           <a:prstGeom prst="rect">
             <a:avLst/>
@@ -6590,7 +6578,7 @@
           </a:extLst>
         </p:spPr>
         <p:txBody>
-          <a:bodyPr lIns="45719" rIns="45719">
+          <a:bodyPr lIns="45718" tIns="45718" rIns="45718" bIns="45718">
             <a:spAutoFit/>
           </a:bodyPr>
           <a:lstStyle/>
@@ -6821,8 +6809,8 @@
         </p:nvSpPr>
         <p:spPr>
           <a:xfrm>
-            <a:off x="860683" y="1560091"/>
-            <a:ext cx="11020854" cy="2156928"/>
+            <a:off x="860682" y="1560091"/>
+            <a:ext cx="11020856" cy="2156926"/>
           </a:xfrm>
           <a:prstGeom prst="rect">
             <a:avLst/>
@@ -6837,7 +6825,7 @@
           </a:extLst>
         </p:spPr>
         <p:txBody>
-          <a:bodyPr lIns="45719" rIns="45719">
+          <a:bodyPr lIns="45718" tIns="45718" rIns="45718" bIns="45718">
             <a:spAutoFit/>
           </a:bodyPr>
           <a:lstStyle/>
@@ -6897,8 +6885,8 @@
         </p:nvSpPr>
         <p:spPr>
           <a:xfrm>
-            <a:off x="860683" y="452095"/>
-            <a:ext cx="10470635" cy="1021034"/>
+            <a:off x="860682" y="452095"/>
+            <a:ext cx="10470637" cy="1021032"/>
           </a:xfrm>
           <a:prstGeom prst="rect">
             <a:avLst/>
@@ -6913,7 +6901,7 @@
           </a:extLst>
         </p:spPr>
         <p:txBody>
-          <a:bodyPr lIns="45719" rIns="45719">
+          <a:bodyPr lIns="45718" tIns="45718" rIns="45718" bIns="45718">
             <a:spAutoFit/>
           </a:bodyPr>
           <a:lstStyle>
@@ -6982,8 +6970,8 @@
         </p:nvSpPr>
         <p:spPr>
           <a:xfrm>
-            <a:off x="531892" y="205503"/>
-            <a:ext cx="10882867" cy="935370"/>
+            <a:off x="531891" y="205503"/>
+            <a:ext cx="10882869" cy="935369"/>
           </a:xfrm>
           <a:prstGeom prst="rect">
             <a:avLst/>
@@ -6998,7 +6986,7 @@
           </a:extLst>
         </p:spPr>
         <p:txBody>
-          <a:bodyPr lIns="45719" rIns="45719">
+          <a:bodyPr lIns="45718" tIns="45718" rIns="45718" bIns="45718">
             <a:spAutoFit/>
           </a:bodyPr>
           <a:lstStyle>
@@ -7030,8 +7018,8 @@
         </p:nvSpPr>
         <p:spPr>
           <a:xfrm>
-            <a:off x="222478" y="1141163"/>
-            <a:ext cx="4585905" cy="666761"/>
+            <a:off x="222478" y="1141164"/>
+            <a:ext cx="4585905" cy="666758"/>
           </a:xfrm>
           <a:prstGeom prst="rect">
             <a:avLst/>
@@ -7046,7 +7034,7 @@
           </a:extLst>
         </p:spPr>
         <p:txBody>
-          <a:bodyPr lIns="45719" rIns="45719">
+          <a:bodyPr lIns="45718" tIns="45718" rIns="45718" bIns="45718">
             <a:spAutoFit/>
           </a:bodyPr>
           <a:lstStyle>
@@ -7078,8 +7066,8 @@
         </p:nvSpPr>
         <p:spPr>
           <a:xfrm>
-            <a:off x="531891" y="1856172"/>
-            <a:ext cx="6290827" cy="662941"/>
+            <a:off x="531890" y="1856173"/>
+            <a:ext cx="6290825" cy="662939"/>
           </a:xfrm>
           <a:prstGeom prst="rect">
             <a:avLst/>
@@ -7094,24 +7082,23 @@
           </a:extLst>
         </p:spPr>
         <p:txBody>
-          <a:bodyPr wrap="none" lIns="45719" rIns="45719">
+          <a:bodyPr wrap="none" lIns="45718" tIns="45718" rIns="45718" bIns="45718">
             <a:spAutoFit/>
           </a:bodyPr>
-          <a:lstStyle/>
-          <a:p>
-            <a:pPr>
+          <a:lstStyle>
+            <a:lvl1pPr>
               <a:defRPr b="1" sz="3200">
                 <a:latin typeface="Times New Roman"/>
                 <a:ea typeface="Times New Roman"/>
                 <a:cs typeface="Times New Roman"/>
                 <a:sym typeface="Times New Roman"/>
               </a:defRPr>
-            </a:pPr>
-            <a:r>
-              <a:t>①</a:t>
-            </a:r>
-            <a:r>
-              <a:t>Download the following data files</a:t>
+            </a:lvl1pPr>
+          </a:lstStyle>
+          <a:p>
+            <a:pPr/>
+            <a:r>
+              <a:t>①Download the following data files</a:t>
             </a:r>
           </a:p>
         </p:txBody>
@@ -7156,8 +7143,8 @@
         </p:nvSpPr>
         <p:spPr>
           <a:xfrm>
-            <a:off x="531891" y="3309982"/>
-            <a:ext cx="10383402" cy="662941"/>
+            <a:off x="531891" y="3309983"/>
+            <a:ext cx="10383399" cy="662939"/>
           </a:xfrm>
           <a:prstGeom prst="rect">
             <a:avLst/>
@@ -7172,24 +7159,23 @@
           </a:extLst>
         </p:spPr>
         <p:txBody>
-          <a:bodyPr wrap="none" lIns="45719" rIns="45719">
+          <a:bodyPr wrap="none" lIns="45718" tIns="45718" rIns="45718" bIns="45718">
             <a:spAutoFit/>
           </a:bodyPr>
-          <a:lstStyle/>
-          <a:p>
-            <a:pPr>
+          <a:lstStyle>
+            <a:lvl1pPr>
               <a:defRPr b="1" sz="3200">
                 <a:latin typeface="Times New Roman"/>
                 <a:ea typeface="Times New Roman"/>
                 <a:cs typeface="Times New Roman"/>
                 <a:sym typeface="Times New Roman"/>
               </a:defRPr>
-            </a:pPr>
-            <a:r>
-              <a:t>②</a:t>
-            </a:r>
-            <a:r>
-              <a:t>Import the txt into the lab2.accdb and create three tables</a:t>
+            </a:lvl1pPr>
+          </a:lstStyle>
+          <a:p>
+            <a:pPr/>
+            <a:r>
+              <a:t>②Import the txt into the lab2.accdb and create three tables</a:t>
             </a:r>
           </a:p>
         </p:txBody>
@@ -7206,15 +7192,15 @@
           <a:blip r:embed="rId3">
             <a:extLst/>
           </a:blip>
-          <a:srcRect l="4814" t="0" r="350" b="51729"/>
+          <a:srcRect l="4814" t="0" r="349" b="51729"/>
           <a:stretch>
             <a:fillRect/>
           </a:stretch>
         </p:blipFill>
         <p:spPr>
           <a:xfrm>
-            <a:off x="837072" y="4486655"/>
-            <a:ext cx="3644251" cy="1832082"/>
+            <a:off x="837071" y="4486654"/>
+            <a:ext cx="3644252" cy="1832083"/>
           </a:xfrm>
           <a:prstGeom prst="rect">
             <a:avLst/>
@@ -7234,8 +7220,8 @@
         </p:nvSpPr>
         <p:spPr>
           <a:xfrm>
-            <a:off x="2182260" y="4040656"/>
-            <a:ext cx="871110" cy="348430"/>
+            <a:off x="2182260" y="4040657"/>
+            <a:ext cx="871111" cy="348428"/>
           </a:xfrm>
           <a:prstGeom prst="rect">
             <a:avLst/>
@@ -7250,7 +7236,7 @@
           </a:extLst>
         </p:spPr>
         <p:txBody>
-          <a:bodyPr lIns="45719" rIns="45719">
+          <a:bodyPr lIns="45718" tIns="45718" rIns="45718" bIns="45718">
             <a:spAutoFit/>
           </a:bodyPr>
           <a:lstStyle>
@@ -7296,8 +7282,8 @@
         </p:blipFill>
         <p:spPr>
           <a:xfrm>
-            <a:off x="5096633" y="4486655"/>
-            <a:ext cx="2636859" cy="1832082"/>
+            <a:off x="5096633" y="4486654"/>
+            <a:ext cx="2636860" cy="1832083"/>
           </a:xfrm>
           <a:prstGeom prst="rect">
             <a:avLst/>
@@ -7317,8 +7303,8 @@
         </p:nvSpPr>
         <p:spPr>
           <a:xfrm>
-            <a:off x="6102870" y="4040656"/>
-            <a:ext cx="871110" cy="348430"/>
+            <a:off x="6102870" y="4040657"/>
+            <a:ext cx="871111" cy="348428"/>
           </a:xfrm>
           <a:prstGeom prst="rect">
             <a:avLst/>
@@ -7333,7 +7319,7 @@
           </a:extLst>
         </p:spPr>
         <p:txBody>
-          <a:bodyPr lIns="45719" rIns="45719">
+          <a:bodyPr lIns="45718" tIns="45718" rIns="45718" bIns="45718">
             <a:spAutoFit/>
           </a:bodyPr>
           <a:lstStyle>
@@ -7368,8 +7354,8 @@
         </p:nvSpPr>
         <p:spPr>
           <a:xfrm>
-            <a:off x="9462824" y="4040656"/>
-            <a:ext cx="1226976" cy="348430"/>
+            <a:off x="9462823" y="4040657"/>
+            <a:ext cx="1226977" cy="348428"/>
           </a:xfrm>
           <a:prstGeom prst="rect">
             <a:avLst/>
@@ -7384,7 +7370,7 @@
           </a:extLst>
         </p:spPr>
         <p:txBody>
-          <a:bodyPr lIns="45719" rIns="45719">
+          <a:bodyPr lIns="45718" tIns="45718" rIns="45718" bIns="45718">
             <a:spAutoFit/>
           </a:bodyPr>
           <a:lstStyle>
@@ -7430,7 +7416,7 @@
         <p:spPr>
           <a:xfrm>
             <a:off x="8673917" y="4470465"/>
-            <a:ext cx="2566368" cy="1832082"/>
+            <a:ext cx="2566369" cy="1832083"/>
           </a:xfrm>
           <a:prstGeom prst="rect">
             <a:avLst/>
@@ -7450,8 +7436,8 @@
         </p:nvSpPr>
         <p:spPr>
           <a:xfrm>
-            <a:off x="6002706" y="1280461"/>
-            <a:ext cx="5342422" cy="624655"/>
+            <a:off x="6002706" y="1280460"/>
+            <a:ext cx="5342423" cy="624653"/>
           </a:xfrm>
           <a:prstGeom prst="rect">
             <a:avLst/>
@@ -7468,7 +7454,7 @@
           </a:extLst>
         </p:spPr>
         <p:txBody>
-          <a:bodyPr lIns="45719" rIns="45719">
+          <a:bodyPr lIns="45718" tIns="45718" rIns="45718" bIns="45718">
             <a:spAutoFit/>
           </a:bodyPr>
           <a:lstStyle>
@@ -7523,8 +7509,8 @@
         </p:nvSpPr>
         <p:spPr>
           <a:xfrm>
-            <a:off x="531892" y="205503"/>
-            <a:ext cx="10882867" cy="935370"/>
+            <a:off x="531891" y="205503"/>
+            <a:ext cx="10882869" cy="935369"/>
           </a:xfrm>
           <a:prstGeom prst="rect">
             <a:avLst/>
@@ -7539,7 +7525,7 @@
           </a:extLst>
         </p:spPr>
         <p:txBody>
-          <a:bodyPr lIns="45719" rIns="45719">
+          <a:bodyPr lIns="45718" tIns="45718" rIns="45718" bIns="45718">
             <a:spAutoFit/>
           </a:bodyPr>
           <a:lstStyle>
@@ -7571,8 +7557,8 @@
         </p:nvSpPr>
         <p:spPr>
           <a:xfrm>
-            <a:off x="222477" y="1141163"/>
-            <a:ext cx="7786305" cy="666761"/>
+            <a:off x="222476" y="1141164"/>
+            <a:ext cx="7786307" cy="666758"/>
           </a:xfrm>
           <a:prstGeom prst="rect">
             <a:avLst/>
@@ -7587,7 +7573,7 @@
           </a:extLst>
         </p:spPr>
         <p:txBody>
-          <a:bodyPr lIns="45719" rIns="45719">
+          <a:bodyPr lIns="45718" tIns="45718" rIns="45718" bIns="45718">
             <a:spAutoFit/>
           </a:bodyPr>
           <a:lstStyle>
@@ -7619,8 +7605,8 @@
         </p:nvSpPr>
         <p:spPr>
           <a:xfrm>
-            <a:off x="531891" y="1856172"/>
-            <a:ext cx="9826779" cy="544077"/>
+            <a:off x="531890" y="1856172"/>
+            <a:ext cx="9826781" cy="544075"/>
           </a:xfrm>
           <a:prstGeom prst="rect">
             <a:avLst/>
@@ -7635,7 +7621,7 @@
           </a:extLst>
         </p:spPr>
         <p:txBody>
-          <a:bodyPr lIns="45719" rIns="45719">
+          <a:bodyPr lIns="45718" tIns="45718" rIns="45718" bIns="45718">
             <a:spAutoFit/>
           </a:bodyPr>
           <a:lstStyle>
@@ -7664,10 +7650,10 @@
         </p:nvGrpSpPr>
         <p:grpSpPr>
           <a:xfrm>
-            <a:off x="486172" y="2751950"/>
-            <a:ext cx="11034338" cy="3323810"/>
+            <a:off x="486172" y="2751949"/>
+            <a:ext cx="11034339" cy="3323813"/>
             <a:chOff x="0" y="0"/>
-            <a:chExt cx="11034337" cy="3323809"/>
+            <a:chExt cx="11034339" cy="3323811"/>
           </a:xfrm>
         </p:grpSpPr>
         <p:pic>
@@ -7688,8 +7674,8 @@
           </p:blipFill>
           <p:spPr>
             <a:xfrm>
-              <a:off x="0" y="0"/>
-              <a:ext cx="5352382" cy="3323810"/>
+              <a:off x="-1" y="-1"/>
+              <a:ext cx="5352384" cy="3323812"/>
             </a:xfrm>
             <a:prstGeom prst="rect">
               <a:avLst/>
@@ -7729,7 +7715,7 @@
           <p:spPr>
             <a:xfrm>
               <a:off x="7253385" y="1111435"/>
-              <a:ext cx="3780953" cy="1123811"/>
+              <a:ext cx="3780955" cy="1123812"/>
             </a:xfrm>
             <a:prstGeom prst="rect">
               <a:avLst/>
@@ -7759,7 +7745,7 @@
           <p:spPr>
             <a:xfrm>
               <a:off x="5352381" y="1661905"/>
-              <a:ext cx="1901005" cy="11436"/>
+              <a:ext cx="1901006" cy="11437"/>
             </a:xfrm>
             <a:prstGeom prst="line">
               <a:avLst/>
@@ -7776,7 +7762,7 @@
             <a:effectLst/>
           </p:spPr>
           <p:txBody>
-            <a:bodyPr wrap="square" lIns="45719" tIns="45719" rIns="45719" bIns="45719" numCol="1" anchor="t">
+            <a:bodyPr wrap="square" lIns="45718" tIns="45718" rIns="45718" bIns="45718" numCol="1" anchor="t">
               <a:noAutofit/>
             </a:bodyPr>
             <a:lstStyle/>
@@ -7794,7 +7780,7 @@
           <p:spPr>
             <a:xfrm>
               <a:off x="5655548" y="1077130"/>
-              <a:ext cx="1422121" cy="544076"/>
+              <a:ext cx="1422122" cy="544075"/>
             </a:xfrm>
             <a:prstGeom prst="rect">
               <a:avLst/>
@@ -7812,7 +7798,7 @@
             </a:extLst>
           </p:spPr>
           <p:txBody>
-            <a:bodyPr wrap="square" lIns="45719" tIns="45719" rIns="45719" bIns="45719" numCol="1" anchor="t">
+            <a:bodyPr wrap="square" lIns="45718" tIns="45718" rIns="45718" bIns="45718" numCol="1" anchor="t">
               <a:spAutoFit/>
             </a:bodyPr>
             <a:lstStyle>
@@ -7868,8 +7854,8 @@
         </p:nvSpPr>
         <p:spPr>
           <a:xfrm>
-            <a:off x="531892" y="205503"/>
-            <a:ext cx="10882867" cy="935370"/>
+            <a:off x="531891" y="205503"/>
+            <a:ext cx="10882869" cy="935369"/>
           </a:xfrm>
           <a:prstGeom prst="rect">
             <a:avLst/>
@@ -7884,7 +7870,7 @@
           </a:extLst>
         </p:spPr>
         <p:txBody>
-          <a:bodyPr lIns="45719" rIns="45719">
+          <a:bodyPr lIns="45718" tIns="45718" rIns="45718" bIns="45718">
             <a:spAutoFit/>
           </a:bodyPr>
           <a:lstStyle>
@@ -7916,8 +7902,8 @@
         </p:nvSpPr>
         <p:spPr>
           <a:xfrm>
-            <a:off x="222477" y="1141163"/>
-            <a:ext cx="7786305" cy="666761"/>
+            <a:off x="222476" y="1141164"/>
+            <a:ext cx="7786307" cy="666758"/>
           </a:xfrm>
           <a:prstGeom prst="rect">
             <a:avLst/>
@@ -7932,7 +7918,7 @@
           </a:extLst>
         </p:spPr>
         <p:txBody>
-          <a:bodyPr lIns="45719" rIns="45719">
+          <a:bodyPr lIns="45718" tIns="45718" rIns="45718" bIns="45718">
             <a:spAutoFit/>
           </a:bodyPr>
           <a:lstStyle>
@@ -7964,8 +7950,8 @@
         </p:nvSpPr>
         <p:spPr>
           <a:xfrm>
-            <a:off x="531891" y="1856172"/>
-            <a:ext cx="9826779" cy="544077"/>
+            <a:off x="531890" y="1856172"/>
+            <a:ext cx="9826781" cy="544075"/>
           </a:xfrm>
           <a:prstGeom prst="rect">
             <a:avLst/>
@@ -7980,27 +7966,23 @@
           </a:extLst>
         </p:spPr>
         <p:txBody>
-          <a:bodyPr lIns="45719" rIns="45719">
+          <a:bodyPr lIns="45718" tIns="45718" rIns="45718" bIns="45718">
             <a:spAutoFit/>
           </a:bodyPr>
-          <a:lstStyle/>
-          <a:p>
-            <a:pPr>
+          <a:lstStyle>
+            <a:lvl1pPr>
               <a:defRPr b="1" sz="3200">
                 <a:latin typeface="Times New Roman"/>
                 <a:ea typeface="Times New Roman"/>
                 <a:cs typeface="Times New Roman"/>
                 <a:sym typeface="Times New Roman"/>
               </a:defRPr>
-            </a:pPr>
-            <a:r>
-              <a:t>Names of sailors who have booked red boats</a:t>
-            </a:r>
-            <a:r>
-              <a:t> </a:t>
-            </a:r>
-            <a:r>
-              <a:t>(1)</a:t>
+            </a:lvl1pPr>
+          </a:lstStyle>
+          <a:p>
+            <a:pPr/>
+            <a:r>
+              <a:t>Find all red boats</a:t>
             </a:r>
           </a:p>
         </p:txBody>
@@ -8039,8 +8021,8 @@
         </p:nvSpPr>
         <p:spPr>
           <a:xfrm>
-            <a:off x="531892" y="205503"/>
-            <a:ext cx="10882867" cy="935370"/>
+            <a:off x="531891" y="205503"/>
+            <a:ext cx="10882869" cy="935369"/>
           </a:xfrm>
           <a:prstGeom prst="rect">
             <a:avLst/>
@@ -8055,7 +8037,7 @@
           </a:extLst>
         </p:spPr>
         <p:txBody>
-          <a:bodyPr lIns="45719" rIns="45719">
+          <a:bodyPr lIns="45718" tIns="45718" rIns="45718" bIns="45718">
             <a:spAutoFit/>
           </a:bodyPr>
           <a:lstStyle>
@@ -8087,8 +8069,8 @@
         </p:nvSpPr>
         <p:spPr>
           <a:xfrm>
-            <a:off x="222477" y="1141163"/>
-            <a:ext cx="7786305" cy="666761"/>
+            <a:off x="222476" y="1141164"/>
+            <a:ext cx="7786307" cy="666758"/>
           </a:xfrm>
           <a:prstGeom prst="rect">
             <a:avLst/>
@@ -8103,7 +8085,7 @@
           </a:extLst>
         </p:spPr>
         <p:txBody>
-          <a:bodyPr lIns="45719" rIns="45719">
+          <a:bodyPr lIns="45718" tIns="45718" rIns="45718" bIns="45718">
             <a:spAutoFit/>
           </a:bodyPr>
           <a:lstStyle>
@@ -8135,8 +8117,8 @@
         </p:nvSpPr>
         <p:spPr>
           <a:xfrm>
-            <a:off x="531891" y="1856172"/>
-            <a:ext cx="9826779" cy="544077"/>
+            <a:off x="531890" y="1856172"/>
+            <a:ext cx="9826781" cy="544075"/>
           </a:xfrm>
           <a:prstGeom prst="rect">
             <a:avLst/>
@@ -8151,27 +8133,23 @@
           </a:extLst>
         </p:spPr>
         <p:txBody>
-          <a:bodyPr lIns="45719" rIns="45719">
+          <a:bodyPr lIns="45718" tIns="45718" rIns="45718" bIns="45718">
             <a:spAutoFit/>
           </a:bodyPr>
-          <a:lstStyle/>
-          <a:p>
-            <a:pPr>
+          <a:lstStyle>
+            <a:lvl1pPr>
               <a:defRPr b="1" sz="3200">
                 <a:latin typeface="Times New Roman"/>
                 <a:ea typeface="Times New Roman"/>
                 <a:cs typeface="Times New Roman"/>
                 <a:sym typeface="Times New Roman"/>
               </a:defRPr>
-            </a:pPr>
-            <a:r>
-              <a:t>Names of sailors who have booked red boats</a:t>
-            </a:r>
-            <a:r>
-              <a:t> </a:t>
-            </a:r>
-            <a:r>
-              <a:t>(2)</a:t>
+            </a:lvl1pPr>
+          </a:lstStyle>
+          <a:p>
+            <a:pPr/>
+            <a:r>
+              <a:t>Find sailors who are older than 40 and have a rating &gt; 7</a:t>
             </a:r>
           </a:p>
         </p:txBody>
@@ -8210,8 +8188,8 @@
         </p:nvSpPr>
         <p:spPr>
           <a:xfrm>
-            <a:off x="531892" y="205503"/>
-            <a:ext cx="10882867" cy="935370"/>
+            <a:off x="531891" y="205503"/>
+            <a:ext cx="10882869" cy="935369"/>
           </a:xfrm>
           <a:prstGeom prst="rect">
             <a:avLst/>
@@ -8226,7 +8204,7 @@
           </a:extLst>
         </p:spPr>
         <p:txBody>
-          <a:bodyPr lIns="45719" rIns="45719">
+          <a:bodyPr lIns="45718" tIns="45718" rIns="45718" bIns="45718">
             <a:spAutoFit/>
           </a:bodyPr>
           <a:lstStyle>
@@ -8258,8 +8236,8 @@
         </p:nvSpPr>
         <p:spPr>
           <a:xfrm>
-            <a:off x="222477" y="1141163"/>
-            <a:ext cx="7786305" cy="666761"/>
+            <a:off x="222476" y="1141164"/>
+            <a:ext cx="7786307" cy="666758"/>
           </a:xfrm>
           <a:prstGeom prst="rect">
             <a:avLst/>
@@ -8274,7 +8252,7 @@
           </a:extLst>
         </p:spPr>
         <p:txBody>
-          <a:bodyPr lIns="45719" rIns="45719">
+          <a:bodyPr lIns="45718" tIns="45718" rIns="45718" bIns="45718">
             <a:spAutoFit/>
           </a:bodyPr>
           <a:lstStyle>
@@ -8307,7 +8285,7 @@
         <p:spPr>
           <a:xfrm>
             <a:off x="531891" y="1856172"/>
-            <a:ext cx="10972311" cy="544077"/>
+            <a:ext cx="10972311" cy="544075"/>
           </a:xfrm>
           <a:prstGeom prst="rect">
             <a:avLst/>
@@ -8322,27 +8300,23 @@
           </a:extLst>
         </p:spPr>
         <p:txBody>
-          <a:bodyPr lIns="45719" rIns="45719">
+          <a:bodyPr lIns="45718" tIns="45718" rIns="45718" bIns="45718">
             <a:spAutoFit/>
           </a:bodyPr>
-          <a:lstStyle/>
-          <a:p>
-            <a:pPr>
+          <a:lstStyle>
+            <a:lvl1pPr>
               <a:defRPr b="1" sz="3200">
                 <a:latin typeface="Times New Roman"/>
                 <a:ea typeface="Times New Roman"/>
                 <a:cs typeface="Times New Roman"/>
                 <a:sym typeface="Times New Roman"/>
               </a:defRPr>
-            </a:pPr>
+            </a:lvl1pPr>
+          </a:lstStyle>
+          <a:p>
+            <a:pPr/>
             <a:r>
               <a:t>Names of sailors who have booked boats within 2019</a:t>
-            </a:r>
-            <a:r>
-              <a:t> </a:t>
-            </a:r>
-            <a:r>
-              <a:t>(1)</a:t>
             </a:r>
           </a:p>
         </p:txBody>
@@ -8399,14 +8373,14 @@
     </a:clrScheme>
     <a:fontScheme name="Office 主题​​">
       <a:majorFont>
+        <a:latin typeface="Helvetica"/>
+        <a:ea typeface="Helvetica"/>
+        <a:cs typeface="Helvetica"/>
+      </a:majorFont>
+      <a:minorFont>
         <a:latin typeface="等线"/>
         <a:ea typeface="等线"/>
         <a:cs typeface="等线"/>
-      </a:majorFont>
-      <a:minorFont>
-        <a:latin typeface="Helvetica"/>
-        <a:ea typeface="Helvetica"/>
-        <a:cs typeface="Helvetica"/>
       </a:minorFont>
     </a:fontScheme>
     <a:fmtScheme name="Office 主题​​">
@@ -8549,17 +8523,17 @@
         <a:solidFill>
           <a:srgbClr val="FFFFFF"/>
         </a:solidFill>
-        <a:ln w="12700" cap="flat">
+        <a:ln w="25400" cap="flat">
           <a:solidFill>
             <a:schemeClr val="accent1"/>
           </a:solidFill>
           <a:prstDash val="solid"/>
-          <a:miter lim="800000"/>
+          <a:round/>
         </a:ln>
         <a:effectLst/>
         <a:sp3d/>
       </a:spPr>
-      <a:bodyPr rot="0" spcFirstLastPara="1" vertOverflow="overflow" horzOverflow="overflow" vert="horz" wrap="square" lIns="45719" tIns="45719" rIns="45719" bIns="45719" numCol="1" spcCol="38100" rtlCol="0" anchor="ctr" upright="0">
+      <a:bodyPr rot="0" spcFirstLastPara="1" vertOverflow="overflow" horzOverflow="overflow" vert="horz" wrap="square" lIns="45718" tIns="45718" rIns="45718" bIns="45718" numCol="1" spcCol="38100" rtlCol="0" anchor="ctr" upright="0">
         <a:spAutoFit/>
       </a:bodyPr>
       <a:lstStyle>
@@ -8587,10 +8561,10 @@
             </a:solidFill>
             <a:effectLst/>
             <a:uFillTx/>
-            <a:latin typeface="Calibri"/>
-            <a:ea typeface="Calibri"/>
-            <a:cs typeface="Calibri"/>
-            <a:sym typeface="Calibri"/>
+            <a:latin typeface="+mj-lt"/>
+            <a:ea typeface="+mj-ea"/>
+            <a:cs typeface="+mj-cs"/>
+            <a:sym typeface="Helvetica"/>
           </a:defRPr>
         </a:defPPr>
         <a:lvl1pPr marL="0" marR="0" indent="0" algn="l" defTabSz="914400" rtl="0" fontAlgn="auto" latinLnBrk="1" hangingPunct="0">
@@ -8838,12 +8812,12 @@
     <a:lnDef>
       <a:spPr>
         <a:noFill/>
-        <a:ln w="12700" cap="flat">
+        <a:ln w="25400" cap="flat">
           <a:solidFill>
             <a:schemeClr val="accent1"/>
           </a:solidFill>
           <a:prstDash val="solid"/>
-          <a:miter lim="800000"/>
+          <a:round/>
         </a:ln>
         <a:effectLst/>
         <a:sp3d/>
@@ -9130,7 +9104,7 @@
         <a:effectLst/>
         <a:sp3d/>
       </a:spPr>
-      <a:bodyPr rot="0" spcFirstLastPara="1" vertOverflow="overflow" horzOverflow="overflow" vert="horz" wrap="square" lIns="45719" tIns="45719" rIns="45719" bIns="45719" numCol="1" spcCol="38100" rtlCol="0" anchor="t" upright="0">
+      <a:bodyPr rot="0" spcFirstLastPara="1" vertOverflow="overflow" horzOverflow="overflow" vert="horz" wrap="square" lIns="45718" tIns="45718" rIns="45718" bIns="45718" numCol="1" spcCol="38100" rtlCol="0" anchor="t" upright="0">
         <a:spAutoFit/>
       </a:bodyPr>
       <a:lstStyle>
@@ -9158,10 +9132,10 @@
             </a:solidFill>
             <a:effectLst/>
             <a:uFillTx/>
-            <a:latin typeface="Calibri"/>
-            <a:ea typeface="Calibri"/>
-            <a:cs typeface="Calibri"/>
-            <a:sym typeface="Calibri"/>
+            <a:latin typeface="+mj-lt"/>
+            <a:ea typeface="+mj-ea"/>
+            <a:cs typeface="+mj-cs"/>
+            <a:sym typeface="Helvetica"/>
           </a:defRPr>
         </a:defPPr>
         <a:lvl1pPr marL="0" marR="0" indent="0" algn="l" defTabSz="914400" rtl="0" fontAlgn="auto" latinLnBrk="1" hangingPunct="0">
@@ -9453,14 +9427,14 @@
     </a:clrScheme>
     <a:fontScheme name="Office 主题​​">
       <a:majorFont>
+        <a:latin typeface="Helvetica"/>
+        <a:ea typeface="Helvetica"/>
+        <a:cs typeface="Helvetica"/>
+      </a:majorFont>
+      <a:minorFont>
         <a:latin typeface="等线"/>
         <a:ea typeface="等线"/>
         <a:cs typeface="等线"/>
-      </a:majorFont>
-      <a:minorFont>
-        <a:latin typeface="Helvetica"/>
-        <a:ea typeface="Helvetica"/>
-        <a:cs typeface="Helvetica"/>
       </a:minorFont>
     </a:fontScheme>
     <a:fmtScheme name="Office 主题​​">
@@ -9603,17 +9577,17 @@
         <a:solidFill>
           <a:srgbClr val="FFFFFF"/>
         </a:solidFill>
-        <a:ln w="12700" cap="flat">
+        <a:ln w="25400" cap="flat">
           <a:solidFill>
             <a:schemeClr val="accent1"/>
           </a:solidFill>
           <a:prstDash val="solid"/>
-          <a:miter lim="800000"/>
+          <a:round/>
         </a:ln>
         <a:effectLst/>
         <a:sp3d/>
       </a:spPr>
-      <a:bodyPr rot="0" spcFirstLastPara="1" vertOverflow="overflow" horzOverflow="overflow" vert="horz" wrap="square" lIns="45719" tIns="45719" rIns="45719" bIns="45719" numCol="1" spcCol="38100" rtlCol="0" anchor="ctr" upright="0">
+      <a:bodyPr rot="0" spcFirstLastPara="1" vertOverflow="overflow" horzOverflow="overflow" vert="horz" wrap="square" lIns="45718" tIns="45718" rIns="45718" bIns="45718" numCol="1" spcCol="38100" rtlCol="0" anchor="ctr" upright="0">
         <a:spAutoFit/>
       </a:bodyPr>
       <a:lstStyle>
@@ -9641,10 +9615,10 @@
             </a:solidFill>
             <a:effectLst/>
             <a:uFillTx/>
-            <a:latin typeface="Calibri"/>
-            <a:ea typeface="Calibri"/>
-            <a:cs typeface="Calibri"/>
-            <a:sym typeface="Calibri"/>
+            <a:latin typeface="+mj-lt"/>
+            <a:ea typeface="+mj-ea"/>
+            <a:cs typeface="+mj-cs"/>
+            <a:sym typeface="Helvetica"/>
           </a:defRPr>
         </a:defPPr>
         <a:lvl1pPr marL="0" marR="0" indent="0" algn="l" defTabSz="914400" rtl="0" fontAlgn="auto" latinLnBrk="1" hangingPunct="0">
@@ -9892,12 +9866,12 @@
     <a:lnDef>
       <a:spPr>
         <a:noFill/>
-        <a:ln w="12700" cap="flat">
+        <a:ln w="25400" cap="flat">
           <a:solidFill>
             <a:schemeClr val="accent1"/>
           </a:solidFill>
           <a:prstDash val="solid"/>
-          <a:miter lim="800000"/>
+          <a:round/>
         </a:ln>
         <a:effectLst/>
         <a:sp3d/>
@@ -10184,7 +10158,7 @@
         <a:effectLst/>
         <a:sp3d/>
       </a:spPr>
-      <a:bodyPr rot="0" spcFirstLastPara="1" vertOverflow="overflow" horzOverflow="overflow" vert="horz" wrap="square" lIns="45719" tIns="45719" rIns="45719" bIns="45719" numCol="1" spcCol="38100" rtlCol="0" anchor="t" upright="0">
+      <a:bodyPr rot="0" spcFirstLastPara="1" vertOverflow="overflow" horzOverflow="overflow" vert="horz" wrap="square" lIns="45718" tIns="45718" rIns="45718" bIns="45718" numCol="1" spcCol="38100" rtlCol="0" anchor="t" upright="0">
         <a:spAutoFit/>
       </a:bodyPr>
       <a:lstStyle>
@@ -10212,10 +10186,10 @@
             </a:solidFill>
             <a:effectLst/>
             <a:uFillTx/>
-            <a:latin typeface="Calibri"/>
-            <a:ea typeface="Calibri"/>
-            <a:cs typeface="Calibri"/>
-            <a:sym typeface="Calibri"/>
+            <a:latin typeface="+mj-lt"/>
+            <a:ea typeface="+mj-ea"/>
+            <a:cs typeface="+mj-cs"/>
+            <a:sym typeface="Helvetica"/>
           </a:defRPr>
         </a:defPPr>
         <a:lvl1pPr marL="0" marR="0" indent="0" algn="l" defTabSz="914400" rtl="0" fontAlgn="auto" latinLnBrk="1" hangingPunct="0">

</xml_diff>